<commit_message>
Rebuild M2 presentation in Hebrew
Co-Authored-By: Claude Sonnet 4.6 <noreply@anthropic.com>
</commit_message>
<xml_diff>
--- a/M2_Appetite_Engineering.pptx
+++ b/M2_Appetite_Engineering.pptx
@@ -3144,7 +3144,7 @@
         </p:nvSpPr>
         <p:spPr>
           <a:xfrm>
-            <a:off x="256032" y="1188720"/>
+            <a:off x="11868912" y="1188720"/>
             <a:ext cx="64008" cy="4114800"/>
           </a:xfrm>
           <a:prstGeom prst="rect">
@@ -3201,14 +3201,14 @@
           </a:bodyPr>
           <a:lstStyle/>
           <a:p>
-            <a:pPr algn="l"/>
+            <a:pPr algn="r"/>
             <a:r>
               <a:rPr sz="5400" b="1" i="0">
                 <a:solidFill>
                   <a:srgbClr val="F0D080"/>
                 </a:solidFill>
               </a:rPr>
-              <a:t>Appetite Engineering</a:t>
+              <a:t>הנדסת התיאבון</a:t>
             </a:r>
           </a:p>
         </p:txBody>
@@ -3235,14 +3235,14 @@
           </a:bodyPr>
           <a:lstStyle/>
           <a:p>
-            <a:pPr algn="l"/>
-            <a:r>
-              <a:rPr sz="3000" b="0" i="0">
+            <a:pPr algn="r"/>
+            <a:r>
+              <a:rPr sz="2800" b="0" i="0">
                 <a:solidFill>
                   <a:srgbClr val="FFFFFF"/>
                 </a:solidFill>
               </a:rPr>
-              <a:t>הנדסת התיאבון</a:t>
+              <a:t>Appetite Engineering</a:t>
             </a:r>
           </a:p>
         </p:txBody>
@@ -3299,7 +3299,7 @@
         <p:spPr>
           <a:xfrm>
             <a:off x="457200" y="3291840"/>
-            <a:ext cx="8229600" cy="594360"/>
+            <a:ext cx="11274552" cy="594360"/>
           </a:xfrm>
           <a:prstGeom prst="rect">
             <a:avLst/>
@@ -3312,14 +3312,14 @@
           </a:bodyPr>
           <a:lstStyle/>
           <a:p>
-            <a:pPr algn="l"/>
+            <a:pPr algn="r"/>
             <a:r>
               <a:rPr sz="1800" b="0" i="1">
                 <a:solidFill>
                   <a:srgbClr val="8B8B8B"/>
                 </a:solidFill>
               </a:rPr>
-              <a:t>ML-powered shawarma navigation — find the best spot near you in seconds.</a:t>
+              <a:t>ניווט שווארמה מבוסס ML — מצא את המקום הטוב ביותר בסביבתך תוך שניות.</a:t>
             </a:r>
           </a:p>
         </p:txBody>
@@ -3378,6 +3378,348 @@
         <p:spPr>
           <a:xfrm>
             <a:off x="365760" y="5257800"/>
+            <a:ext cx="2743200" cy="502920"/>
+          </a:xfrm>
+          <a:prstGeom prst="rect">
+            <a:avLst/>
+          </a:prstGeom>
+          <a:noFill/>
+        </p:spPr>
+        <p:txBody>
+          <a:bodyPr wrap="square">
+            <a:spAutoFit/>
+          </a:bodyPr>
+          <a:lstStyle/>
+          <a:p>
+            <a:pPr algn="ctr"/>
+            <a:r>
+              <a:rPr sz="1500" b="1" i="0">
+                <a:solidFill>
+                  <a:srgbClr val="C9A84C"/>
+                </a:solidFill>
+              </a:rPr>
+              <a:t>3:15–4:00</a:t>
+            </a:r>
+          </a:p>
+        </p:txBody>
+      </p:sp>
+      <p:sp>
+        <p:nvSpPr>
+          <p:cNvPr id="10" name="TextBox 9"/>
+          <p:cNvSpPr txBox="1"/>
+          <p:nvPr/>
+        </p:nvSpPr>
+        <p:spPr>
+          <a:xfrm>
+            <a:off x="365760" y="5760720"/>
+            <a:ext cx="2743200" cy="640080"/>
+          </a:xfrm>
+          <a:prstGeom prst="rect">
+            <a:avLst/>
+          </a:prstGeom>
+          <a:noFill/>
+        </p:spPr>
+        <p:txBody>
+          <a:bodyPr wrap="square">
+            <a:spAutoFit/>
+          </a:bodyPr>
+          <a:lstStyle/>
+          <a:p>
+            <a:pPr algn="ctr"/>
+            <a:r>
+              <a:rPr sz="1300" b="0" i="0">
+                <a:solidFill>
+                  <a:srgbClr val="FFFFFF"/>
+                </a:solidFill>
+              </a:rPr>
+              <a:t>KPI +
+צעד הבא</a:t>
+            </a:r>
+          </a:p>
+        </p:txBody>
+      </p:sp>
+      <p:sp>
+        <p:nvSpPr>
+          <p:cNvPr id="11" name="Rectangle 10"/>
+          <p:cNvSpPr/>
+          <p:nvPr/>
+        </p:nvSpPr>
+        <p:spPr>
+          <a:xfrm>
+            <a:off x="3319272" y="5212080"/>
+            <a:ext cx="2743200" cy="1325880"/>
+          </a:xfrm>
+          <a:prstGeom prst="rect">
+            <a:avLst/>
+          </a:prstGeom>
+          <a:solidFill>
+            <a:srgbClr val="1A202C"/>
+          </a:solidFill>
+          <a:ln w="19050">
+            <a:solidFill>
+              <a:srgbClr val="C9A84C"/>
+            </a:solidFill>
+          </a:ln>
+        </p:spPr>
+        <p:style>
+          <a:lnRef idx="1">
+            <a:schemeClr val="accent1"/>
+          </a:lnRef>
+          <a:fillRef idx="3">
+            <a:schemeClr val="accent1"/>
+          </a:fillRef>
+          <a:effectRef idx="2">
+            <a:schemeClr val="accent1"/>
+          </a:effectRef>
+          <a:fontRef idx="minor">
+            <a:schemeClr val="lt1"/>
+          </a:fontRef>
+        </p:style>
+        <p:txBody>
+          <a:bodyPr rtlCol="0" anchor="ctr"/>
+          <a:lstStyle/>
+          <a:p>
+            <a:pPr algn="ctr"/>
+          </a:p>
+        </p:txBody>
+      </p:sp>
+      <p:sp>
+        <p:nvSpPr>
+          <p:cNvPr id="12" name="TextBox 11"/>
+          <p:cNvSpPr txBox="1"/>
+          <p:nvPr/>
+        </p:nvSpPr>
+        <p:spPr>
+          <a:xfrm>
+            <a:off x="3319272" y="5257800"/>
+            <a:ext cx="2743200" cy="502920"/>
+          </a:xfrm>
+          <a:prstGeom prst="rect">
+            <a:avLst/>
+          </a:prstGeom>
+          <a:noFill/>
+        </p:spPr>
+        <p:txBody>
+          <a:bodyPr wrap="square">
+            <a:spAutoFit/>
+          </a:bodyPr>
+          <a:lstStyle/>
+          <a:p>
+            <a:pPr algn="ctr"/>
+            <a:r>
+              <a:rPr sz="1500" b="1" i="0">
+                <a:solidFill>
+                  <a:srgbClr val="C9A84C"/>
+                </a:solidFill>
+              </a:rPr>
+              <a:t>1:45–3:15</a:t>
+            </a:r>
+          </a:p>
+        </p:txBody>
+      </p:sp>
+      <p:sp>
+        <p:nvSpPr>
+          <p:cNvPr id="13" name="TextBox 12"/>
+          <p:cNvSpPr txBox="1"/>
+          <p:nvPr/>
+        </p:nvSpPr>
+        <p:spPr>
+          <a:xfrm>
+            <a:off x="3319272" y="5760720"/>
+            <a:ext cx="2743200" cy="640080"/>
+          </a:xfrm>
+          <a:prstGeom prst="rect">
+            <a:avLst/>
+          </a:prstGeom>
+          <a:noFill/>
+        </p:spPr>
+        <p:txBody>
+          <a:bodyPr wrap="square">
+            <a:spAutoFit/>
+          </a:bodyPr>
+          <a:lstStyle/>
+          <a:p>
+            <a:pPr algn="ctr"/>
+            <a:r>
+              <a:rPr sz="1300" b="0" i="0">
+                <a:solidFill>
+                  <a:srgbClr val="FFFFFF"/>
+                </a:solidFill>
+              </a:rPr>
+              <a:t>EDA +
+תובנות</a:t>
+            </a:r>
+          </a:p>
+        </p:txBody>
+      </p:sp>
+      <p:sp>
+        <p:nvSpPr>
+          <p:cNvPr id="14" name="Rectangle 13"/>
+          <p:cNvSpPr/>
+          <p:nvPr/>
+        </p:nvSpPr>
+        <p:spPr>
+          <a:xfrm>
+            <a:off x="6272784" y="5212080"/>
+            <a:ext cx="2743200" cy="1325880"/>
+          </a:xfrm>
+          <a:prstGeom prst="rect">
+            <a:avLst/>
+          </a:prstGeom>
+          <a:solidFill>
+            <a:srgbClr val="1A202C"/>
+          </a:solidFill>
+          <a:ln w="19050">
+            <a:solidFill>
+              <a:srgbClr val="C9A84C"/>
+            </a:solidFill>
+          </a:ln>
+        </p:spPr>
+        <p:style>
+          <a:lnRef idx="1">
+            <a:schemeClr val="accent1"/>
+          </a:lnRef>
+          <a:fillRef idx="3">
+            <a:schemeClr val="accent1"/>
+          </a:fillRef>
+          <a:effectRef idx="2">
+            <a:schemeClr val="accent1"/>
+          </a:effectRef>
+          <a:fontRef idx="minor">
+            <a:schemeClr val="lt1"/>
+          </a:fontRef>
+        </p:style>
+        <p:txBody>
+          <a:bodyPr rtlCol="0" anchor="ctr"/>
+          <a:lstStyle/>
+          <a:p>
+            <a:pPr algn="ctr"/>
+          </a:p>
+        </p:txBody>
+      </p:sp>
+      <p:sp>
+        <p:nvSpPr>
+          <p:cNvPr id="15" name="TextBox 14"/>
+          <p:cNvSpPr txBox="1"/>
+          <p:nvPr/>
+        </p:nvSpPr>
+        <p:spPr>
+          <a:xfrm>
+            <a:off x="6272784" y="5257800"/>
+            <a:ext cx="2743200" cy="502920"/>
+          </a:xfrm>
+          <a:prstGeom prst="rect">
+            <a:avLst/>
+          </a:prstGeom>
+          <a:noFill/>
+        </p:spPr>
+        <p:txBody>
+          <a:bodyPr wrap="square">
+            <a:spAutoFit/>
+          </a:bodyPr>
+          <a:lstStyle/>
+          <a:p>
+            <a:pPr algn="ctr"/>
+            <a:r>
+              <a:rPr sz="1500" b="1" i="0">
+                <a:solidFill>
+                  <a:srgbClr val="C9A84C"/>
+                </a:solidFill>
+              </a:rPr>
+              <a:t>0:45–1:45</a:t>
+            </a:r>
+          </a:p>
+        </p:txBody>
+      </p:sp>
+      <p:sp>
+        <p:nvSpPr>
+          <p:cNvPr id="16" name="TextBox 15"/>
+          <p:cNvSpPr txBox="1"/>
+          <p:nvPr/>
+        </p:nvSpPr>
+        <p:spPr>
+          <a:xfrm>
+            <a:off x="6272784" y="5760720"/>
+            <a:ext cx="2743200" cy="640080"/>
+          </a:xfrm>
+          <a:prstGeom prst="rect">
+            <a:avLst/>
+          </a:prstGeom>
+          <a:noFill/>
+        </p:spPr>
+        <p:txBody>
+          <a:bodyPr wrap="square">
+            <a:spAutoFit/>
+          </a:bodyPr>
+          <a:lstStyle/>
+          <a:p>
+            <a:pPr algn="ctr"/>
+            <a:r>
+              <a:rPr sz="1300" b="0" i="0">
+                <a:solidFill>
+                  <a:srgbClr val="FFFFFF"/>
+                </a:solidFill>
+              </a:rPr>
+              <a:t>ספרות
++ שוק</a:t>
+            </a:r>
+          </a:p>
+        </p:txBody>
+      </p:sp>
+      <p:sp>
+        <p:nvSpPr>
+          <p:cNvPr id="17" name="Rectangle 16"/>
+          <p:cNvSpPr/>
+          <p:nvPr/>
+        </p:nvSpPr>
+        <p:spPr>
+          <a:xfrm>
+            <a:off x="9226296" y="5212080"/>
+            <a:ext cx="2743200" cy="1325880"/>
+          </a:xfrm>
+          <a:prstGeom prst="rect">
+            <a:avLst/>
+          </a:prstGeom>
+          <a:solidFill>
+            <a:srgbClr val="1A202C"/>
+          </a:solidFill>
+          <a:ln w="19050">
+            <a:solidFill>
+              <a:srgbClr val="C9A84C"/>
+            </a:solidFill>
+          </a:ln>
+        </p:spPr>
+        <p:style>
+          <a:lnRef idx="1">
+            <a:schemeClr val="accent1"/>
+          </a:lnRef>
+          <a:fillRef idx="3">
+            <a:schemeClr val="accent1"/>
+          </a:fillRef>
+          <a:effectRef idx="2">
+            <a:schemeClr val="accent1"/>
+          </a:effectRef>
+          <a:fontRef idx="minor">
+            <a:schemeClr val="lt1"/>
+          </a:fontRef>
+        </p:style>
+        <p:txBody>
+          <a:bodyPr rtlCol="0" anchor="ctr"/>
+          <a:lstStyle/>
+          <a:p>
+            <a:pPr algn="ctr"/>
+          </a:p>
+        </p:txBody>
+      </p:sp>
+      <p:sp>
+        <p:nvSpPr>
+          <p:cNvPr id="18" name="TextBox 17"/>
+          <p:cNvSpPr txBox="1"/>
+          <p:nvPr/>
+        </p:nvSpPr>
+        <p:spPr>
+          <a:xfrm>
+            <a:off x="9226296" y="5257800"/>
             <a:ext cx="2743200" cy="502920"/>
           </a:xfrm>
           <a:prstGeom prst="rect">
@@ -3405,13 +3747,13 @@
       </p:sp>
       <p:sp>
         <p:nvSpPr>
-          <p:cNvPr id="10" name="TextBox 9"/>
+          <p:cNvPr id="19" name="TextBox 18"/>
           <p:cNvSpPr txBox="1"/>
           <p:nvPr/>
         </p:nvSpPr>
         <p:spPr>
           <a:xfrm>
-            <a:off x="365760" y="5760720"/>
+            <a:off x="9226296" y="5760720"/>
             <a:ext cx="2743200" cy="640080"/>
           </a:xfrm>
           <a:prstGeom prst="rect">
@@ -3432,67 +3774,22 @@
                   <a:srgbClr val="FFFFFF"/>
                 </a:solidFill>
               </a:rPr>
-              <a:t>Problem &amp;
-Value Prop</a:t>
-            </a:r>
-          </a:p>
-        </p:txBody>
-      </p:sp>
-      <p:sp>
-        <p:nvSpPr>
-          <p:cNvPr id="11" name="Rectangle 10"/>
-          <p:cNvSpPr/>
-          <p:nvPr/>
-        </p:nvSpPr>
-        <p:spPr>
-          <a:xfrm>
-            <a:off x="3319272" y="5212080"/>
-            <a:ext cx="2743200" cy="1325880"/>
-          </a:xfrm>
-          <a:prstGeom prst="rect">
-            <a:avLst/>
-          </a:prstGeom>
-          <a:solidFill>
-            <a:srgbClr val="1A202C"/>
-          </a:solidFill>
-          <a:ln w="19050">
-            <a:solidFill>
-              <a:srgbClr val="C9A84C"/>
-            </a:solidFill>
-          </a:ln>
-        </p:spPr>
-        <p:style>
-          <a:lnRef idx="1">
-            <a:schemeClr val="accent1"/>
-          </a:lnRef>
-          <a:fillRef idx="3">
-            <a:schemeClr val="accent1"/>
-          </a:fillRef>
-          <a:effectRef idx="2">
-            <a:schemeClr val="accent1"/>
-          </a:effectRef>
-          <a:fontRef idx="minor">
-            <a:schemeClr val="lt1"/>
-          </a:fontRef>
-        </p:style>
-        <p:txBody>
-          <a:bodyPr rtlCol="0" anchor="ctr"/>
-          <a:lstStyle/>
-          <a:p>
-            <a:pPr algn="ctr"/>
-          </a:p>
-        </p:txBody>
-      </p:sp>
-      <p:sp>
-        <p:nvSpPr>
-          <p:cNvPr id="12" name="TextBox 11"/>
+              <a:t>בעיה +
+הצעת ערך</a:t>
+            </a:r>
+          </a:p>
+        </p:txBody>
+      </p:sp>
+      <p:sp>
+        <p:nvSpPr>
+          <p:cNvPr id="20" name="TextBox 19"/>
           <p:cNvSpPr txBox="1"/>
           <p:nvPr/>
         </p:nvSpPr>
         <p:spPr>
           <a:xfrm>
-            <a:off x="3319272" y="5257800"/>
-            <a:ext cx="2743200" cy="502920"/>
+            <a:off x="457200" y="6537960"/>
+            <a:ext cx="11274552" cy="274320"/>
           </a:xfrm>
           <a:prstGeom prst="rect">
             <a:avLst/>
@@ -3505,311 +3802,14 @@
           </a:bodyPr>
           <a:lstStyle/>
           <a:p>
-            <a:pPr algn="ctr"/>
-            <a:r>
-              <a:rPr sz="1500" b="1" i="0">
-                <a:solidFill>
-                  <a:srgbClr val="C9A84C"/>
-                </a:solidFill>
-              </a:rPr>
-              <a:t>0:45–1:45</a:t>
-            </a:r>
-          </a:p>
-        </p:txBody>
-      </p:sp>
-      <p:sp>
-        <p:nvSpPr>
-          <p:cNvPr id="13" name="TextBox 12"/>
-          <p:cNvSpPr txBox="1"/>
-          <p:nvPr/>
-        </p:nvSpPr>
-        <p:spPr>
-          <a:xfrm>
-            <a:off x="3319272" y="5760720"/>
-            <a:ext cx="2743200" cy="640080"/>
-          </a:xfrm>
-          <a:prstGeom prst="rect">
-            <a:avLst/>
-          </a:prstGeom>
-          <a:noFill/>
-        </p:spPr>
-        <p:txBody>
-          <a:bodyPr wrap="square">
-            <a:spAutoFit/>
-          </a:bodyPr>
-          <a:lstStyle/>
-          <a:p>
-            <a:pPr algn="ctr"/>
-            <a:r>
-              <a:rPr sz="1300" b="0" i="0">
-                <a:solidFill>
-                  <a:srgbClr val="FFFFFF"/>
-                </a:solidFill>
-              </a:rPr>
-              <a:t>Literature
-&amp; Market</a:t>
-            </a:r>
-          </a:p>
-        </p:txBody>
-      </p:sp>
-      <p:sp>
-        <p:nvSpPr>
-          <p:cNvPr id="14" name="Rectangle 13"/>
-          <p:cNvSpPr/>
-          <p:nvPr/>
-        </p:nvSpPr>
-        <p:spPr>
-          <a:xfrm>
-            <a:off x="6272784" y="5212080"/>
-            <a:ext cx="2743200" cy="1325880"/>
-          </a:xfrm>
-          <a:prstGeom prst="rect">
-            <a:avLst/>
-          </a:prstGeom>
-          <a:solidFill>
-            <a:srgbClr val="1A202C"/>
-          </a:solidFill>
-          <a:ln w="19050">
-            <a:solidFill>
-              <a:srgbClr val="C9A84C"/>
-            </a:solidFill>
-          </a:ln>
-        </p:spPr>
-        <p:style>
-          <a:lnRef idx="1">
-            <a:schemeClr val="accent1"/>
-          </a:lnRef>
-          <a:fillRef idx="3">
-            <a:schemeClr val="accent1"/>
-          </a:fillRef>
-          <a:effectRef idx="2">
-            <a:schemeClr val="accent1"/>
-          </a:effectRef>
-          <a:fontRef idx="minor">
-            <a:schemeClr val="lt1"/>
-          </a:fontRef>
-        </p:style>
-        <p:txBody>
-          <a:bodyPr rtlCol="0" anchor="ctr"/>
-          <a:lstStyle/>
-          <a:p>
-            <a:pPr algn="ctr"/>
-          </a:p>
-        </p:txBody>
-      </p:sp>
-      <p:sp>
-        <p:nvSpPr>
-          <p:cNvPr id="15" name="TextBox 14"/>
-          <p:cNvSpPr txBox="1"/>
-          <p:nvPr/>
-        </p:nvSpPr>
-        <p:spPr>
-          <a:xfrm>
-            <a:off x="6272784" y="5257800"/>
-            <a:ext cx="2743200" cy="502920"/>
-          </a:xfrm>
-          <a:prstGeom prst="rect">
-            <a:avLst/>
-          </a:prstGeom>
-          <a:noFill/>
-        </p:spPr>
-        <p:txBody>
-          <a:bodyPr wrap="square">
-            <a:spAutoFit/>
-          </a:bodyPr>
-          <a:lstStyle/>
-          <a:p>
-            <a:pPr algn="ctr"/>
-            <a:r>
-              <a:rPr sz="1500" b="1" i="0">
-                <a:solidFill>
-                  <a:srgbClr val="C9A84C"/>
-                </a:solidFill>
-              </a:rPr>
-              <a:t>1:45–3:15</a:t>
-            </a:r>
-          </a:p>
-        </p:txBody>
-      </p:sp>
-      <p:sp>
-        <p:nvSpPr>
-          <p:cNvPr id="16" name="TextBox 15"/>
-          <p:cNvSpPr txBox="1"/>
-          <p:nvPr/>
-        </p:nvSpPr>
-        <p:spPr>
-          <a:xfrm>
-            <a:off x="6272784" y="5760720"/>
-            <a:ext cx="2743200" cy="640080"/>
-          </a:xfrm>
-          <a:prstGeom prst="rect">
-            <a:avLst/>
-          </a:prstGeom>
-          <a:noFill/>
-        </p:spPr>
-        <p:txBody>
-          <a:bodyPr wrap="square">
-            <a:spAutoFit/>
-          </a:bodyPr>
-          <a:lstStyle/>
-          <a:p>
-            <a:pPr algn="ctr"/>
-            <a:r>
-              <a:rPr sz="1300" b="0" i="0">
-                <a:solidFill>
-                  <a:srgbClr val="FFFFFF"/>
-                </a:solidFill>
-              </a:rPr>
-              <a:t>EDA &amp;
-Insights</a:t>
-            </a:r>
-          </a:p>
-        </p:txBody>
-      </p:sp>
-      <p:sp>
-        <p:nvSpPr>
-          <p:cNvPr id="17" name="Rectangle 16"/>
-          <p:cNvSpPr/>
-          <p:nvPr/>
-        </p:nvSpPr>
-        <p:spPr>
-          <a:xfrm>
-            <a:off x="9226296" y="5212080"/>
-            <a:ext cx="2743200" cy="1325880"/>
-          </a:xfrm>
-          <a:prstGeom prst="rect">
-            <a:avLst/>
-          </a:prstGeom>
-          <a:solidFill>
-            <a:srgbClr val="1A202C"/>
-          </a:solidFill>
-          <a:ln w="19050">
-            <a:solidFill>
-              <a:srgbClr val="C9A84C"/>
-            </a:solidFill>
-          </a:ln>
-        </p:spPr>
-        <p:style>
-          <a:lnRef idx="1">
-            <a:schemeClr val="accent1"/>
-          </a:lnRef>
-          <a:fillRef idx="3">
-            <a:schemeClr val="accent1"/>
-          </a:fillRef>
-          <a:effectRef idx="2">
-            <a:schemeClr val="accent1"/>
-          </a:effectRef>
-          <a:fontRef idx="minor">
-            <a:schemeClr val="lt1"/>
-          </a:fontRef>
-        </p:style>
-        <p:txBody>
-          <a:bodyPr rtlCol="0" anchor="ctr"/>
-          <a:lstStyle/>
-          <a:p>
-            <a:pPr algn="ctr"/>
-          </a:p>
-        </p:txBody>
-      </p:sp>
-      <p:sp>
-        <p:nvSpPr>
-          <p:cNvPr id="18" name="TextBox 17"/>
-          <p:cNvSpPr txBox="1"/>
-          <p:nvPr/>
-        </p:nvSpPr>
-        <p:spPr>
-          <a:xfrm>
-            <a:off x="9226296" y="5257800"/>
-            <a:ext cx="2743200" cy="502920"/>
-          </a:xfrm>
-          <a:prstGeom prst="rect">
-            <a:avLst/>
-          </a:prstGeom>
-          <a:noFill/>
-        </p:spPr>
-        <p:txBody>
-          <a:bodyPr wrap="square">
-            <a:spAutoFit/>
-          </a:bodyPr>
-          <a:lstStyle/>
-          <a:p>
-            <a:pPr algn="ctr"/>
-            <a:r>
-              <a:rPr sz="1500" b="1" i="0">
-                <a:solidFill>
-                  <a:srgbClr val="C9A84C"/>
-                </a:solidFill>
-              </a:rPr>
-              <a:t>3:15–4:00</a:t>
-            </a:r>
-          </a:p>
-        </p:txBody>
-      </p:sp>
-      <p:sp>
-        <p:nvSpPr>
-          <p:cNvPr id="19" name="TextBox 18"/>
-          <p:cNvSpPr txBox="1"/>
-          <p:nvPr/>
-        </p:nvSpPr>
-        <p:spPr>
-          <a:xfrm>
-            <a:off x="9226296" y="5760720"/>
-            <a:ext cx="2743200" cy="640080"/>
-          </a:xfrm>
-          <a:prstGeom prst="rect">
-            <a:avLst/>
-          </a:prstGeom>
-          <a:noFill/>
-        </p:spPr>
-        <p:txBody>
-          <a:bodyPr wrap="square">
-            <a:spAutoFit/>
-          </a:bodyPr>
-          <a:lstStyle/>
-          <a:p>
-            <a:pPr algn="ctr"/>
-            <a:r>
-              <a:rPr sz="1300" b="0" i="0">
-                <a:solidFill>
-                  <a:srgbClr val="FFFFFF"/>
-                </a:solidFill>
-              </a:rPr>
-              <a:t>KPI &amp;
-Next Steps</a:t>
-            </a:r>
-          </a:p>
-        </p:txBody>
-      </p:sp>
-      <p:sp>
-        <p:nvSpPr>
-          <p:cNvPr id="20" name="TextBox 19"/>
-          <p:cNvSpPr txBox="1"/>
-          <p:nvPr/>
-        </p:nvSpPr>
-        <p:spPr>
-          <a:xfrm>
-            <a:off x="457200" y="6537960"/>
-            <a:ext cx="11274552" cy="274320"/>
-          </a:xfrm>
-          <a:prstGeom prst="rect">
-            <a:avLst/>
-          </a:prstGeom>
-          <a:noFill/>
-        </p:spPr>
-        <p:txBody>
-          <a:bodyPr wrap="square">
-            <a:spAutoFit/>
-          </a:bodyPr>
-          <a:lstStyle/>
-          <a:p>
-            <a:pPr algn="l"/>
+            <a:pPr algn="r"/>
             <a:r>
               <a:rPr sz="1100" b="0" i="0">
                 <a:solidFill>
                   <a:srgbClr val="8B8B8B"/>
                 </a:solidFill>
               </a:rPr>
-              <a:t>Gidi Horesh &amp; Eliad  ·  Technion LBS Course  ·  M2  ·  2026</a:t>
+              <a:t>גידי הורש ואליאד  ·  קורס שירותים מבוססי מיקום  ·  הטכניון  ·  M2  ·  2026</a:t>
             </a:r>
           </a:p>
         </p:txBody>
@@ -3883,7 +3883,7 @@
         </p:nvSpPr>
         <p:spPr>
           <a:xfrm>
-            <a:off x="365760" y="182880"/>
+            <a:off x="9509760" y="182880"/>
             <a:ext cx="2286000" cy="502920"/>
           </a:xfrm>
           <a:prstGeom prst="rect">
@@ -3928,7 +3928,7 @@
         </p:nvSpPr>
         <p:spPr>
           <a:xfrm>
-            <a:off x="365760" y="182880"/>
+            <a:off x="9509760" y="182880"/>
             <a:ext cx="2286000" cy="502920"/>
           </a:xfrm>
           <a:prstGeom prst="rect">
@@ -3962,7 +3962,7 @@
         </p:nvSpPr>
         <p:spPr>
           <a:xfrm>
-            <a:off x="2834640" y="228600"/>
+            <a:off x="365760" y="228600"/>
             <a:ext cx="8961120" cy="411480"/>
           </a:xfrm>
           <a:prstGeom prst="rect">
@@ -3976,14 +3976,14 @@
           </a:bodyPr>
           <a:lstStyle/>
           <a:p>
-            <a:pPr algn="l"/>
+            <a:pPr algn="r"/>
             <a:r>
               <a:rPr sz="1200" b="0" i="0">
                 <a:solidFill>
                   <a:srgbClr val="8B8B8B"/>
                 </a:solidFill>
               </a:rPr>
-              <a:t>Section 1 / 4</a:t>
+              <a:t>חלק 1 מתוך 4</a:t>
             </a:r>
           </a:p>
         </p:txBody>
@@ -4010,14 +4010,14 @@
           </a:bodyPr>
           <a:lstStyle/>
           <a:p>
-            <a:pPr algn="l"/>
+            <a:pPr algn="r"/>
             <a:r>
               <a:rPr sz="3000" b="1" i="0">
                 <a:solidFill>
                   <a:srgbClr val="F0D080"/>
                 </a:solidFill>
               </a:rPr>
-              <a:t>Problem &amp; Value Proposition</a:t>
+              <a:t>הבעיה והצעת הערך</a:t>
             </a:r>
           </a:p>
         </p:txBody>
@@ -4132,14 +4132,14 @@
           </a:bodyPr>
           <a:lstStyle/>
           <a:p>
-            <a:pPr algn="l"/>
+            <a:pPr algn="r"/>
             <a:r>
               <a:rPr sz="1800" b="1" i="0">
                 <a:solidFill>
                   <a:srgbClr val="E63A46"/>
                 </a:solidFill>
               </a:rPr>
-              <a:t>❌  The Problem</a:t>
+              <a:t>❌  הבעיה</a:t>
             </a:r>
           </a:p>
         </p:txBody>
@@ -4166,14 +4166,14 @@
           </a:bodyPr>
           <a:lstStyle/>
           <a:p>
-            <a:pPr algn="l"/>
+            <a:pPr algn="r"/>
             <a:r>
               <a:rPr sz="1400" b="0" i="0">
                 <a:solidFill>
                   <a:srgbClr val="FFFFFF"/>
                 </a:solidFill>
               </a:rPr>
-              <a:t>You're in a city. It's lunchtime. You want shawarma.</a:t>
+              <a:t>אתה בעיר. זה שעת הצהריים. בא לך שווארמה.</a:t>
             </a:r>
           </a:p>
         </p:txBody>
@@ -4200,14 +4200,14 @@
           </a:bodyPr>
           <a:lstStyle/>
           <a:p>
-            <a:pPr algn="l"/>
+            <a:pPr algn="r"/>
             <a:r>
               <a:rPr sz="1400" b="0" i="0">
                 <a:solidFill>
                   <a:srgbClr val="FFFFFF"/>
                 </a:solidFill>
               </a:rPr>
-              <a:t>Google Maps returns 50+ results — no price, no real ranking.</a:t>
+              <a:t>גוגל מפות מחזיר 50+ תוצאות — אין מחיר, אין דירוג אמיתי.</a:t>
             </a:r>
           </a:p>
         </p:txBody>
@@ -4234,14 +4234,14 @@
           </a:bodyPr>
           <a:lstStyle/>
           <a:p>
-            <a:pPr algn="l"/>
+            <a:pPr algn="r"/>
             <a:r>
               <a:rPr sz="1400" b="0" i="0">
                 <a:solidFill>
                   <a:srgbClr val="FFFFFF"/>
                 </a:solidFill>
               </a:rPr>
-              <a:t>You don't know which ones are truly close AND good.</a:t>
+              <a:t>אין לך דרך לדעת איזה מקום קרוב וגם טוב.</a:t>
             </a:r>
           </a:p>
         </p:txBody>
@@ -4268,14 +4268,14 @@
           </a:bodyPr>
           <a:lstStyle/>
           <a:p>
-            <a:pPr algn="l"/>
+            <a:pPr algn="r"/>
             <a:r>
               <a:rPr sz="1400" b="0" i="0">
                 <a:solidFill>
                   <a:srgbClr val="FFFFFF"/>
                 </a:solidFill>
               </a:rPr>
-              <a:t>You end up picking a familiar name, overpay by ₪7-11,</a:t>
+              <a:t>בסוף בוחרים מקום מוכר, משלמים ₪7–11 יותר,</a:t>
             </a:r>
           </a:p>
         </p:txBody>
@@ -4302,14 +4302,14 @@
           </a:bodyPr>
           <a:lstStyle/>
           <a:p>
-            <a:pPr algn="l"/>
+            <a:pPr algn="r"/>
             <a:r>
               <a:rPr sz="1400" b="0" i="0">
                 <a:solidFill>
                   <a:srgbClr val="FFFFFF"/>
                 </a:solidFill>
               </a:rPr>
-              <a:t>and get a mediocre experience.</a:t>
+              <a:t>ומקבלים חוויה בינונית.</a:t>
             </a:r>
           </a:p>
         </p:txBody>
@@ -4336,7 +4336,7 @@
           </a:bodyPr>
           <a:lstStyle/>
           <a:p>
-            <a:pPr algn="l"/>
+            <a:pPr algn="r"/>
             <a:r>
               <a:rPr sz="1400" b="0" i="0">
                 <a:solidFill>
@@ -4370,14 +4370,14 @@
           </a:bodyPr>
           <a:lstStyle/>
           <a:p>
-            <a:pPr algn="l"/>
+            <a:pPr algn="r"/>
             <a:r>
               <a:rPr sz="1400" b="0" i="0">
                 <a:solidFill>
                   <a:srgbClr val="FFFFFF"/>
                 </a:solidFill>
               </a:rPr>
-              <a:t>Finding a high-quality, nearby shawarma with</a:t>
+              <a:t>מציאת שווארמה איכותית ובמרחק הליכה</a:t>
             </a:r>
           </a:p>
         </p:txBody>
@@ -4404,28 +4404,62 @@
           </a:bodyPr>
           <a:lstStyle/>
           <a:p>
-            <a:pPr algn="l"/>
+            <a:pPr algn="r"/>
             <a:r>
               <a:rPr sz="1400" b="0" i="0">
                 <a:solidFill>
                   <a:srgbClr val="FFFFFF"/>
                 </a:solidFill>
               </a:rPr>
-              <a:t>minimum effort is unsolved.</a:t>
-            </a:r>
-          </a:p>
-        </p:txBody>
-      </p:sp>
-      <p:sp>
-        <p:nvSpPr>
-          <p:cNvPr id="18" name="Rectangle 17"/>
-          <p:cNvSpPr/>
-          <p:nvPr/>
-        </p:nvSpPr>
-        <p:spPr>
-          <a:xfrm>
-            <a:off x="6309360" y="1828800"/>
-            <a:ext cx="5486400" cy="4480560"/>
+              <a:t>עם מינימום מאמץ — עדיין לא פתורה.</a:t>
+            </a:r>
+          </a:p>
+        </p:txBody>
+      </p:sp>
+      <p:sp>
+        <p:nvSpPr>
+          <p:cNvPr id="18" name="TextBox 17"/>
+          <p:cNvSpPr txBox="1"/>
+          <p:nvPr/>
+        </p:nvSpPr>
+        <p:spPr>
+          <a:xfrm>
+            <a:off x="5760720" y="3749039"/>
+            <a:ext cx="640080" cy="640080"/>
+          </a:xfrm>
+          <a:prstGeom prst="rect">
+            <a:avLst/>
+          </a:prstGeom>
+          <a:noFill/>
+        </p:spPr>
+        <p:txBody>
+          <a:bodyPr wrap="square">
+            <a:spAutoFit/>
+          </a:bodyPr>
+          <a:lstStyle/>
+          <a:p>
+            <a:pPr algn="ctr"/>
+            <a:r>
+              <a:rPr sz="3200" b="1" i="0">
+                <a:solidFill>
+                  <a:srgbClr val="C9A84C"/>
+                </a:solidFill>
+              </a:rPr>
+              <a:t>←</a:t>
+            </a:r>
+          </a:p>
+        </p:txBody>
+      </p:sp>
+      <p:sp>
+        <p:nvSpPr>
+          <p:cNvPr id="19" name="Rectangle 18"/>
+          <p:cNvSpPr/>
+          <p:nvPr/>
+        </p:nvSpPr>
+        <p:spPr>
+          <a:xfrm>
+            <a:off x="6400800" y="1828800"/>
+            <a:ext cx="5394960" cy="4480560"/>
           </a:xfrm>
           <a:prstGeom prst="rect">
             <a:avLst/>
@@ -4463,13 +4497,13 @@
       </p:sp>
       <p:sp>
         <p:nvSpPr>
-          <p:cNvPr id="19" name="TextBox 18"/>
+          <p:cNvPr id="20" name="TextBox 19"/>
           <p:cNvSpPr txBox="1"/>
           <p:nvPr/>
         </p:nvSpPr>
         <p:spPr>
           <a:xfrm>
-            <a:off x="6446520" y="1920240"/>
+            <a:off x="6492240" y="1920240"/>
             <a:ext cx="5212080" cy="502920"/>
           </a:xfrm>
           <a:prstGeom prst="rect">
@@ -4483,27 +4517,27 @@
           </a:bodyPr>
           <a:lstStyle/>
           <a:p>
-            <a:pPr algn="l"/>
+            <a:pPr algn="r"/>
             <a:r>
               <a:rPr sz="1800" b="1" i="0">
                 <a:solidFill>
                   <a:srgbClr val="C9A84C"/>
                 </a:solidFill>
               </a:rPr>
-              <a:t>✅  Value Proposition</a:t>
-            </a:r>
-          </a:p>
-        </p:txBody>
-      </p:sp>
-      <p:sp>
-        <p:nvSpPr>
-          <p:cNvPr id="20" name="TextBox 19"/>
+              <a:t>✅  הצעת הערך</a:t>
+            </a:r>
+          </a:p>
+        </p:txBody>
+      </p:sp>
+      <p:sp>
+        <p:nvSpPr>
+          <p:cNvPr id="21" name="TextBox 20"/>
           <p:cNvSpPr txBox="1"/>
           <p:nvPr/>
         </p:nvSpPr>
         <p:spPr>
           <a:xfrm>
-            <a:off x="6446520" y="2560320"/>
+            <a:off x="6492240" y="2514600"/>
             <a:ext cx="5212080" cy="594360"/>
           </a:xfrm>
           <a:prstGeom prst="rect">
@@ -4517,28 +4551,28 @@
           </a:bodyPr>
           <a:lstStyle/>
           <a:p>
-            <a:pPr algn="l"/>
-            <a:r>
-              <a:rPr sz="2000" b="1" i="0">
+            <a:pPr algn="r"/>
+            <a:r>
+              <a:rPr sz="1800" b="1" i="0">
                 <a:solidFill>
                   <a:srgbClr val="F0D080"/>
                 </a:solidFill>
               </a:rPr>
-              <a:t>One tap. Best shawarma near you.</a:t>
-            </a:r>
-          </a:p>
-        </p:txBody>
-      </p:sp>
-      <p:sp>
-        <p:nvSpPr>
-          <p:cNvPr id="21" name="TextBox 20"/>
+              <a:t>לחיצה אחת. השווארמה הטובה ביותר בסביבתך.</a:t>
+            </a:r>
+          </a:p>
+        </p:txBody>
+      </p:sp>
+      <p:sp>
+        <p:nvSpPr>
+          <p:cNvPr id="22" name="TextBox 21"/>
           <p:cNvSpPr txBox="1"/>
           <p:nvPr/>
         </p:nvSpPr>
         <p:spPr>
           <a:xfrm>
-            <a:off x="6492240" y="3246120"/>
-            <a:ext cx="1645920" cy="438912"/>
+            <a:off x="6492240" y="3200400"/>
+            <a:ext cx="5212080" cy="438912"/>
           </a:xfrm>
           <a:prstGeom prst="rect">
             <a:avLst/>
@@ -4551,48 +4585,14 @@
           </a:bodyPr>
           <a:lstStyle/>
           <a:p>
-            <a:pPr algn="l"/>
-            <a:r>
-              <a:rPr sz="1400" b="1" i="0">
-                <a:solidFill>
-                  <a:srgbClr val="C9A84C"/>
-                </a:solidFill>
-              </a:rPr>
-              <a:t>🎯  Relevant:</a:t>
-            </a:r>
-          </a:p>
-        </p:txBody>
-      </p:sp>
-      <p:sp>
-        <p:nvSpPr>
-          <p:cNvPr id="22" name="TextBox 21"/>
-          <p:cNvSpPr txBox="1"/>
-          <p:nvPr/>
-        </p:nvSpPr>
-        <p:spPr>
-          <a:xfrm>
-            <a:off x="8183879" y="3246120"/>
-            <a:ext cx="3429000" cy="438912"/>
-          </a:xfrm>
-          <a:prstGeom prst="rect">
-            <a:avLst/>
-          </a:prstGeom>
-          <a:noFill/>
-        </p:spPr>
-        <p:txBody>
-          <a:bodyPr wrap="square">
-            <a:spAutoFit/>
-          </a:bodyPr>
-          <a:lstStyle/>
-          <a:p>
-            <a:pPr algn="l"/>
+            <a:pPr algn="r"/>
             <a:r>
               <a:rPr sz="1400" b="0" i="0">
                 <a:solidFill>
                   <a:srgbClr val="FFFFFF"/>
                 </a:solidFill>
               </a:rPr>
-              <a:t>Only shawarma — no generic restaurant noise.</a:t>
+              <a:t>שווארמה בלבד — ללא רעש של מסעדות כלליות.  :רלוונטי  🎯</a:t>
             </a:r>
           </a:p>
         </p:txBody>
@@ -4605,8 +4605,8 @@
         </p:nvSpPr>
         <p:spPr>
           <a:xfrm>
-            <a:off x="6492240" y="3685032"/>
-            <a:ext cx="1645920" cy="438912"/>
+            <a:off x="6492240" y="3639312"/>
+            <a:ext cx="5212080" cy="438912"/>
           </a:xfrm>
           <a:prstGeom prst="rect">
             <a:avLst/>
@@ -4619,62 +4619,28 @@
           </a:bodyPr>
           <a:lstStyle/>
           <a:p>
-            <a:pPr algn="l"/>
-            <a:r>
-              <a:rPr sz="1400" b="1" i="0">
-                <a:solidFill>
-                  <a:srgbClr val="C9A84C"/>
-                </a:solidFill>
-              </a:rPr>
-              <a:t>⚡  Fast:</a:t>
-            </a:r>
-          </a:p>
-        </p:txBody>
-      </p:sp>
-      <p:sp>
-        <p:nvSpPr>
-          <p:cNvPr id="24" name="TextBox 23"/>
-          <p:cNvSpPr txBox="1"/>
-          <p:nvPr/>
-        </p:nvSpPr>
-        <p:spPr>
-          <a:xfrm>
-            <a:off x="8183879" y="3685032"/>
-            <a:ext cx="3429000" cy="438912"/>
-          </a:xfrm>
-          <a:prstGeom prst="rect">
-            <a:avLst/>
-          </a:prstGeom>
-          <a:noFill/>
-        </p:spPr>
-        <p:txBody>
-          <a:bodyPr wrap="square">
-            <a:spAutoFit/>
-          </a:bodyPr>
-          <a:lstStyle/>
-          <a:p>
-            <a:pPr algn="l"/>
+            <a:pPr algn="r"/>
             <a:r>
               <a:rPr sz="1400" b="0" i="0">
                 <a:solidFill>
                   <a:srgbClr val="FFFFFF"/>
                 </a:solidFill>
               </a:rPr>
-              <a:t>GPS + ML ranking in under 3 seconds.</a:t>
-            </a:r>
-          </a:p>
-        </p:txBody>
-      </p:sp>
-      <p:sp>
-        <p:nvSpPr>
-          <p:cNvPr id="25" name="TextBox 24"/>
+              <a:t>GPS + דירוג ML תוך פחות מ-3 שניות.  :מהיר  ⚡</a:t>
+            </a:r>
+          </a:p>
+        </p:txBody>
+      </p:sp>
+      <p:sp>
+        <p:nvSpPr>
+          <p:cNvPr id="24" name="TextBox 23"/>
           <p:cNvSpPr txBox="1"/>
           <p:nvPr/>
         </p:nvSpPr>
         <p:spPr>
           <a:xfrm>
-            <a:off x="6492240" y="4123944"/>
-            <a:ext cx="1645920" cy="438912"/>
+            <a:off x="6492240" y="4078224"/>
+            <a:ext cx="5212080" cy="438912"/>
           </a:xfrm>
           <a:prstGeom prst="rect">
             <a:avLst/>
@@ -4687,62 +4653,28 @@
           </a:bodyPr>
           <a:lstStyle/>
           <a:p>
-            <a:pPr algn="l"/>
-            <a:r>
-              <a:rPr sz="1400" b="1" i="0">
-                <a:solidFill>
-                  <a:srgbClr val="C9A84C"/>
-                </a:solidFill>
-              </a:rPr>
-              <a:t>💎  Quality:</a:t>
-            </a:r>
-          </a:p>
-        </p:txBody>
-      </p:sp>
-      <p:sp>
-        <p:nvSpPr>
-          <p:cNvPr id="26" name="TextBox 25"/>
-          <p:cNvSpPr txBox="1"/>
-          <p:nvPr/>
-        </p:nvSpPr>
-        <p:spPr>
-          <a:xfrm>
-            <a:off x="8183879" y="4123944"/>
-            <a:ext cx="3429000" cy="438912"/>
-          </a:xfrm>
-          <a:prstGeom prst="rect">
-            <a:avLst/>
-          </a:prstGeom>
-          <a:noFill/>
-        </p:spPr>
-        <p:txBody>
-          <a:bodyPr wrap="square">
-            <a:spAutoFit/>
-          </a:bodyPr>
-          <a:lstStyle/>
-          <a:p>
-            <a:pPr algn="l"/>
+            <a:pPr algn="r"/>
             <a:r>
               <a:rPr sz="1400" b="0" i="0">
                 <a:solidFill>
                   <a:srgbClr val="FFFFFF"/>
                 </a:solidFill>
               </a:rPr>
-              <a:t>Sorted by rating × price × distance combined.</a:t>
-            </a:r>
-          </a:p>
-        </p:txBody>
-      </p:sp>
-      <p:sp>
-        <p:nvSpPr>
-          <p:cNvPr id="27" name="TextBox 26"/>
+              <a:t>מיון לפי דירוג × מחיר × מרחק משולב.  :איכות  💎</a:t>
+            </a:r>
+          </a:p>
+        </p:txBody>
+      </p:sp>
+      <p:sp>
+        <p:nvSpPr>
+          <p:cNvPr id="25" name="TextBox 24"/>
           <p:cNvSpPr txBox="1"/>
           <p:nvPr/>
         </p:nvSpPr>
         <p:spPr>
           <a:xfrm>
-            <a:off x="6492240" y="4562856"/>
-            <a:ext cx="1645920" cy="438912"/>
+            <a:off x="6492240" y="4517136"/>
+            <a:ext cx="5212080" cy="438912"/>
           </a:xfrm>
           <a:prstGeom prst="rect">
             <a:avLst/>
@@ -4755,62 +4687,28 @@
           </a:bodyPr>
           <a:lstStyle/>
           <a:p>
-            <a:pPr algn="l"/>
-            <a:r>
-              <a:rPr sz="1400" b="1" i="0">
-                <a:solidFill>
-                  <a:srgbClr val="C9A84C"/>
-                </a:solidFill>
-              </a:rPr>
-              <a:t>📍  Nearby:</a:t>
-            </a:r>
-          </a:p>
-        </p:txBody>
-      </p:sp>
-      <p:sp>
-        <p:nvSpPr>
-          <p:cNvPr id="28" name="TextBox 27"/>
-          <p:cNvSpPr txBox="1"/>
-          <p:nvPr/>
-        </p:nvSpPr>
-        <p:spPr>
-          <a:xfrm>
-            <a:off x="8183879" y="4562856"/>
-            <a:ext cx="3429000" cy="438912"/>
-          </a:xfrm>
-          <a:prstGeom prst="rect">
-            <a:avLst/>
-          </a:prstGeom>
-          <a:noFill/>
-        </p:spPr>
-        <p:txBody>
-          <a:bodyPr wrap="square">
-            <a:spAutoFit/>
-          </a:bodyPr>
-          <a:lstStyle/>
-          <a:p>
-            <a:pPr algn="l"/>
+            <a:pPr algn="r"/>
             <a:r>
               <a:rPr sz="1400" b="0" i="0">
                 <a:solidFill>
                   <a:srgbClr val="FFFFFF"/>
                 </a:solidFill>
               </a:rPr>
-              <a:t>Real distance from where you are right now.</a:t>
-            </a:r>
-          </a:p>
-        </p:txBody>
-      </p:sp>
-      <p:sp>
-        <p:nvSpPr>
-          <p:cNvPr id="29" name="TextBox 28"/>
+              <a:t>מרחק אמיתי ממיקומך הנוכחי.  :קרוב  📍</a:t>
+            </a:r>
+          </a:p>
+        </p:txBody>
+      </p:sp>
+      <p:sp>
+        <p:nvSpPr>
+          <p:cNvPr id="26" name="TextBox 25"/>
           <p:cNvSpPr txBox="1"/>
           <p:nvPr/>
         </p:nvSpPr>
         <p:spPr>
           <a:xfrm>
-            <a:off x="6492240" y="5001768"/>
-            <a:ext cx="1645920" cy="438912"/>
+            <a:off x="6492240" y="4956048"/>
+            <a:ext cx="5212080" cy="438912"/>
           </a:xfrm>
           <a:prstGeom prst="rect">
             <a:avLst/>
@@ -4823,48 +4721,14 @@
           </a:bodyPr>
           <a:lstStyle/>
           <a:p>
-            <a:pPr algn="l"/>
-            <a:r>
-              <a:rPr sz="1400" b="1" i="0">
-                <a:solidFill>
-                  <a:srgbClr val="C9A84C"/>
-                </a:solidFill>
-              </a:rPr>
-              <a:t>🏆  Best value:</a:t>
-            </a:r>
-          </a:p>
-        </p:txBody>
-      </p:sp>
-      <p:sp>
-        <p:nvSpPr>
-          <p:cNvPr id="30" name="TextBox 29"/>
-          <p:cNvSpPr txBox="1"/>
-          <p:nvPr/>
-        </p:nvSpPr>
-        <p:spPr>
-          <a:xfrm>
-            <a:off x="8183879" y="5001768"/>
-            <a:ext cx="3429000" cy="438912"/>
-          </a:xfrm>
-          <a:prstGeom prst="rect">
-            <a:avLst/>
-          </a:prstGeom>
-          <a:noFill/>
-        </p:spPr>
-        <p:txBody>
-          <a:bodyPr wrap="square">
-            <a:spAutoFit/>
-          </a:bodyPr>
-          <a:lstStyle/>
-          <a:p>
-            <a:pPr algn="l"/>
+            <a:pPr algn="r"/>
             <a:r>
               <a:rPr sz="1400" b="0" i="0">
                 <a:solidFill>
                   <a:srgbClr val="FFFFFF"/>
                 </a:solidFill>
               </a:rPr>
-              <a:t>No compromise — quality AND price optimized.</a:t>
+              <a:t>ללא פשרות — איכות ומחיר מאוזנים.  :ערך מקסימלי  🏆</a:t>
             </a:r>
           </a:p>
         </p:txBody>
@@ -4938,7 +4802,7 @@
         </p:nvSpPr>
         <p:spPr>
           <a:xfrm>
-            <a:off x="365760" y="182880"/>
+            <a:off x="9509760" y="182880"/>
             <a:ext cx="2286000" cy="502920"/>
           </a:xfrm>
           <a:prstGeom prst="rect">
@@ -4983,7 +4847,7 @@
         </p:nvSpPr>
         <p:spPr>
           <a:xfrm>
-            <a:off x="365760" y="182880"/>
+            <a:off x="9509760" y="182880"/>
             <a:ext cx="2286000" cy="502920"/>
           </a:xfrm>
           <a:prstGeom prst="rect">
@@ -5017,7 +4881,7 @@
         </p:nvSpPr>
         <p:spPr>
           <a:xfrm>
-            <a:off x="2834640" y="228600"/>
+            <a:off x="365760" y="228600"/>
             <a:ext cx="8961120" cy="411480"/>
           </a:xfrm>
           <a:prstGeom prst="rect">
@@ -5031,14 +4895,14 @@
           </a:bodyPr>
           <a:lstStyle/>
           <a:p>
-            <a:pPr algn="l"/>
+            <a:pPr algn="r"/>
             <a:r>
               <a:rPr sz="1200" b="0" i="0">
                 <a:solidFill>
                   <a:srgbClr val="8B8B8B"/>
                 </a:solidFill>
               </a:rPr>
-              <a:t>Section 2 / 4</a:t>
+              <a:t>חלק 2 מתוך 4</a:t>
             </a:r>
           </a:p>
         </p:txBody>
@@ -5065,14 +4929,14 @@
           </a:bodyPr>
           <a:lstStyle/>
           <a:p>
-            <a:pPr algn="l"/>
+            <a:pPr algn="r"/>
             <a:r>
               <a:rPr sz="3000" b="1" i="0">
                 <a:solidFill>
                   <a:srgbClr val="F0D080"/>
                 </a:solidFill>
               </a:rPr>
-              <a:t>Literature Review — What the Research Tells Us</a:t>
+              <a:t>סקירת ספרות — מה המחקר אומר</a:t>
             </a:r>
           </a:p>
         </p:txBody>
@@ -5251,7 +5115,7 @@
         <p:spPr>
           <a:xfrm>
             <a:off x="1005840" y="1874520"/>
-            <a:ext cx="10058400" cy="438912"/>
+            <a:ext cx="10789920" cy="411480"/>
           </a:xfrm>
           <a:prstGeom prst="rect">
             <a:avLst/>
@@ -5264,14 +5128,14 @@
           </a:bodyPr>
           <a:lstStyle/>
           <a:p>
-            <a:pPr algn="l"/>
+            <a:pPr algn="r"/>
             <a:r>
               <a:rPr sz="1500" b="1" i="0">
                 <a:solidFill>
                   <a:srgbClr val="2A9D8F"/>
                 </a:solidFill>
               </a:rPr>
-              <a:t>Food &amp; Sentiment Are Directly Linked</a:t>
+              <a:t>קיים קשר ישיר בין אוכל לרגשות</a:t>
             </a:r>
           </a:p>
         </p:txBody>
@@ -5285,7 +5149,7 @@
         <p:spPr>
           <a:xfrm>
             <a:off x="1005840" y="2286000"/>
-            <a:ext cx="10058400" cy="274320"/>
+            <a:ext cx="10789920" cy="256032"/>
           </a:xfrm>
           <a:prstGeom prst="rect">
             <a:avLst/>
@@ -5298,14 +5162,14 @@
           </a:bodyPr>
           <a:lstStyle/>
           <a:p>
-            <a:pPr algn="l"/>
-            <a:r>
-              <a:rPr sz="1100" b="0" i="1">
+            <a:pPr algn="r"/>
+            <a:r>
+              <a:rPr sz="1000" b="0" i="1">
                 <a:solidFill>
                   <a:srgbClr val="8B8B8B"/>
                 </a:solidFill>
               </a:rPr>
-              <a:t>Asani et al. (2021) — Restaurant Recommender via Sentiment Analysis</a:t>
+              <a:t>Asani et al. (2021) — מערכת המלצות מסעדות מבוססת ניתוח סנטימנט</a:t>
             </a:r>
           </a:p>
         </p:txBody>
@@ -5318,8 +5182,8 @@
         </p:nvSpPr>
         <p:spPr>
           <a:xfrm>
-            <a:off x="1005840" y="2578608"/>
-            <a:ext cx="10607040" cy="594360"/>
+            <a:off x="1005840" y="2542032"/>
+            <a:ext cx="10789920" cy="640080"/>
           </a:xfrm>
           <a:prstGeom prst="rect">
             <a:avLst/>
@@ -5332,15 +5196,16 @@
           </a:bodyPr>
           <a:lstStyle/>
           <a:p>
-            <a:pPr algn="l"/>
+            <a:pPr algn="r"/>
             <a:r>
               <a:rPr sz="1200" b="0" i="0">
                 <a:solidFill>
                   <a:srgbClr val="FFFFFF"/>
                 </a:solidFill>
               </a:rPr>
-              <a:t>User ratings and reviews carry strong emotional signals. Sentiment-based scoring outperforms star-count alone.
-→ Our model incorporates rating as a quality proxy for sentiment — a high rating reflects genuine satisfaction, not just popularity.</a:t>
+              <a:t>דירוגי משתמשים ותגובות נושאים אות רגשי חזק. ניקוד מבוסס סנטימנט
+מדויק יותר ממספר כוכבים לבדו.
+← המודל שלנו משתמש בדירוג כפרוקסי לשביעות רצון אמיתית.</a:t>
             </a:r>
           </a:p>
         </p:txBody>
@@ -5476,7 +5341,7 @@
         <p:spPr>
           <a:xfrm>
             <a:off x="1005840" y="3447288"/>
-            <a:ext cx="10058400" cy="438912"/>
+            <a:ext cx="10789920" cy="411480"/>
           </a:xfrm>
           <a:prstGeom prst="rect">
             <a:avLst/>
@@ -5489,14 +5354,14 @@
           </a:bodyPr>
           <a:lstStyle/>
           <a:p>
-            <a:pPr algn="l"/>
+            <a:pPr algn="r"/>
             <a:r>
               <a:rPr sz="1500" b="1" i="0">
                 <a:solidFill>
                   <a:srgbClr val="C9A84C"/>
                 </a:solidFill>
               </a:rPr>
-              <a:t>Food RS Are Good — But Fail on Specific Food Types</a:t>
+              <a:t>מערכות המלצות מזון טובות — אך לא יעילות לסוגי מזון ספציפיים</a:t>
             </a:r>
           </a:p>
         </p:txBody>
@@ -5510,7 +5375,7 @@
         <p:spPr>
           <a:xfrm>
             <a:off x="1005840" y="3858768"/>
-            <a:ext cx="10058400" cy="274320"/>
+            <a:ext cx="10789920" cy="256032"/>
           </a:xfrm>
           <a:prstGeom prst="rect">
             <a:avLst/>
@@ -5523,14 +5388,14 @@
           </a:bodyPr>
           <a:lstStyle/>
           <a:p>
-            <a:pPr algn="l"/>
-            <a:r>
-              <a:rPr sz="1100" b="0" i="1">
+            <a:pPr algn="r"/>
+            <a:r>
+              <a:rPr sz="1000" b="0" i="1">
                 <a:solidFill>
                   <a:srgbClr val="8B8B8B"/>
                 </a:solidFill>
               </a:rPr>
-              <a:t>Bondevik et al. (2024) — Systematic Review of Food Recommender Systems</a:t>
+              <a:t>Bondevik et al. (2024) — סקירה שיטתית של מערכות המלצות מזון</a:t>
             </a:r>
           </a:p>
         </p:txBody>
@@ -5543,8 +5408,8 @@
         </p:nvSpPr>
         <p:spPr>
           <a:xfrm>
-            <a:off x="1005840" y="4151376"/>
-            <a:ext cx="10607040" cy="594360"/>
+            <a:off x="1005840" y="4114800"/>
+            <a:ext cx="10789920" cy="640080"/>
           </a:xfrm>
           <a:prstGeom prst="rect">
             <a:avLst/>
@@ -5557,15 +5422,17 @@
           </a:bodyPr>
           <a:lstStyle/>
           <a:p>
-            <a:pPr algn="l"/>
+            <a:pPr algn="r"/>
             <a:r>
               <a:rPr sz="1200" b="0" i="0">
                 <a:solidFill>
                   <a:srgbClr val="FFFFFF"/>
                 </a:solidFill>
               </a:rPr>
-              <a:t>64.8% of food RS use ML, yet most target broad restaurant categories. Niche food types (e.g. shawarma) are underserved — generic systems dilute results with irrelevant options.
-→ Specializing on shawarma gives us a signal-to-noise advantage over every general-purpose platform.</a:t>
+              <a:t>64.8% ממערכות ה-FRS משתמשות ב-ML, אך רובן מכוונות לקטגוריות רחבות.
+סוגי מזון נישתיים (כמו שווארמה) מקבלים שירות חסר — מערכות כלליות
+מדללות את התוצאות בפריטים לא רלוונטיים.
+← התמחות בשווארמה נותנת לנו יתרון יחס אות-לרעש.</a:t>
             </a:r>
           </a:p>
         </p:txBody>
@@ -5701,7 +5568,7 @@
         <p:spPr>
           <a:xfrm>
             <a:off x="1005840" y="5020056"/>
-            <a:ext cx="10058400" cy="438912"/>
+            <a:ext cx="10789920" cy="411480"/>
           </a:xfrm>
           <a:prstGeom prst="rect">
             <a:avLst/>
@@ -5714,14 +5581,14 @@
           </a:bodyPr>
           <a:lstStyle/>
           <a:p>
-            <a:pPr algn="l"/>
+            <a:pPr algn="r"/>
             <a:r>
               <a:rPr sz="1500" b="1" i="0">
                 <a:solidFill>
                   <a:srgbClr val="5B8DE0"/>
                 </a:solidFill>
               </a:rPr>
-              <a:t>FRS Do Not Account for User Preferences</a:t>
+              <a:t>מערכות FRS אינן לוקחות בחשבון את העדפות המשתמש</a:t>
             </a:r>
           </a:p>
         </p:txBody>
@@ -5735,7 +5602,7 @@
         <p:spPr>
           <a:xfrm>
             <a:off x="1005840" y="5431536"/>
-            <a:ext cx="10058400" cy="274320"/>
+            <a:ext cx="10789920" cy="256032"/>
           </a:xfrm>
           <a:prstGeom prst="rect">
             <a:avLst/>
@@ -5748,14 +5615,14 @@
           </a:bodyPr>
           <a:lstStyle/>
           <a:p>
-            <a:pPr algn="l"/>
-            <a:r>
-              <a:rPr sz="1100" b="0" i="1">
+            <a:pPr algn="r"/>
+            <a:r>
+              <a:rPr sz="1000" b="0" i="1">
                 <a:solidFill>
                   <a:srgbClr val="8B8B8B"/>
                 </a:solidFill>
               </a:rPr>
-              <a:t>Villegas et al. (2018) — Context-Aware Recommender Systems</a:t>
+              <a:t>Villegas et al. (2018) — מערכות המלצות מודעות הקשר</a:t>
             </a:r>
           </a:p>
         </p:txBody>
@@ -5768,8 +5635,8 @@
         </p:nvSpPr>
         <p:spPr>
           <a:xfrm>
-            <a:off x="1005840" y="5724144"/>
-            <a:ext cx="10607040" cy="594360"/>
+            <a:off x="1005840" y="5687568"/>
+            <a:ext cx="10789920" cy="640080"/>
           </a:xfrm>
           <a:prstGeom prst="rect">
             <a:avLst/>
@@ -5782,15 +5649,17 @@
           </a:bodyPr>
           <a:lstStyle/>
           <a:p>
-            <a:pPr algn="l"/>
+            <a:pPr algn="r"/>
             <a:r>
               <a:rPr sz="1200" b="0" i="0">
                 <a:solidFill>
                   <a:srgbClr val="FFFFFF"/>
                 </a:solidFill>
               </a:rPr>
-              <a:t>74% of context-aware RS use contextual modeling yet still ignore real-time user constraints (budget, distance tolerance, quality floor). Static filters miss the dynamic trade-off each user faces.
-→ Our ML ranking fuses price + rating + distance into a single preference-aware score — no static filter required.</a:t>
+              <a:t>74% ממערכות CARS משתמשות במידול הקשרי אך עדיין מתעלמות ממגבלות
+המשתמש בזמן אמת (תקציב, מרחק, רף איכות). פילטרים סטטיים מחמיצים
+את האיזון הדינמי שכל משתמש זקוק לו.
+← הדירוג שלנו מאחד מחיר + דירוג + מרחק לציון מותאם אחד.</a:t>
             </a:r>
           </a:p>
         </p:txBody>
@@ -5864,7 +5733,7 @@
         </p:nvSpPr>
         <p:spPr>
           <a:xfrm>
-            <a:off x="365760" y="182880"/>
+            <a:off x="9509760" y="182880"/>
             <a:ext cx="2286000" cy="502920"/>
           </a:xfrm>
           <a:prstGeom prst="rect">
@@ -5909,7 +5778,7 @@
         </p:nvSpPr>
         <p:spPr>
           <a:xfrm>
-            <a:off x="365760" y="182880"/>
+            <a:off x="9509760" y="182880"/>
             <a:ext cx="2286000" cy="502920"/>
           </a:xfrm>
           <a:prstGeom prst="rect">
@@ -5943,7 +5812,7 @@
         </p:nvSpPr>
         <p:spPr>
           <a:xfrm>
-            <a:off x="2834640" y="228600"/>
+            <a:off x="365760" y="228600"/>
             <a:ext cx="8961120" cy="411480"/>
           </a:xfrm>
           <a:prstGeom prst="rect">
@@ -5957,14 +5826,14 @@
           </a:bodyPr>
           <a:lstStyle/>
           <a:p>
-            <a:pPr algn="l"/>
+            <a:pPr algn="r"/>
             <a:r>
               <a:rPr sz="1200" b="0" i="0">
                 <a:solidFill>
                   <a:srgbClr val="8B8B8B"/>
                 </a:solidFill>
               </a:rPr>
-              <a:t>Section 2 / 4</a:t>
+              <a:t>חלק 2 מתוך 4</a:t>
             </a:r>
           </a:p>
         </p:txBody>
@@ -5991,14 +5860,14 @@
           </a:bodyPr>
           <a:lstStyle/>
           <a:p>
-            <a:pPr algn="l"/>
+            <a:pPr algn="r"/>
             <a:r>
               <a:rPr sz="3000" b="1" i="0">
                 <a:solidFill>
                   <a:srgbClr val="F0D080"/>
                 </a:solidFill>
               </a:rPr>
-              <a:t>Market &amp; Competition — Where We Fit</a:t>
+              <a:t>ניתוח שוק ותחרות — היכן אנחנו ממוקמים</a:t>
             </a:r>
           </a:p>
         </p:txBody>
@@ -6055,7 +5924,7 @@
         <p:spPr>
           <a:xfrm>
             <a:off x="365760" y="1920240"/>
-            <a:ext cx="1920240" cy="502920"/>
+            <a:ext cx="2011680" cy="502920"/>
           </a:xfrm>
           <a:prstGeom prst="rect">
             <a:avLst/>
@@ -6098,7 +5967,7 @@
         <p:spPr>
           <a:xfrm>
             <a:off x="411480" y="1947672"/>
-            <a:ext cx="1828800" cy="457200"/>
+            <a:ext cx="1920240" cy="457200"/>
           </a:xfrm>
           <a:prstGeom prst="rect">
             <a:avLst/>
@@ -6118,7 +5987,7 @@
                   <a:srgbClr val="C9A84C"/>
                 </a:solidFill>
               </a:rPr>
-              <a:t>Platform</a:t>
+              <a:t>פלטפורמה</a:t>
             </a:r>
           </a:p>
         </p:txBody>
@@ -6131,7 +6000,7 @@
         </p:nvSpPr>
         <p:spPr>
           <a:xfrm>
-            <a:off x="2286000" y="1920240"/>
+            <a:off x="2377440" y="1920240"/>
             <a:ext cx="1554480" cy="502920"/>
           </a:xfrm>
           <a:prstGeom prst="rect">
@@ -6174,7 +6043,7 @@
         </p:nvSpPr>
         <p:spPr>
           <a:xfrm>
-            <a:off x="2331720" y="1947672"/>
+            <a:off x="2423160" y="1947672"/>
             <a:ext cx="1463040" cy="457200"/>
           </a:xfrm>
           <a:prstGeom prst="rect">
@@ -6195,7 +6064,7 @@
                   <a:srgbClr val="C9A84C"/>
                 </a:solidFill>
               </a:rPr>
-              <a:t>Exact ₪ Price</a:t>
+              <a:t>מחיר ₪ מדויק</a:t>
             </a:r>
           </a:p>
         </p:txBody>
@@ -6208,7 +6077,7 @@
         </p:nvSpPr>
         <p:spPr>
           <a:xfrm>
-            <a:off x="3840480" y="1920240"/>
+            <a:off x="3931920" y="1920240"/>
             <a:ext cx="1920240" cy="502920"/>
           </a:xfrm>
           <a:prstGeom prst="rect">
@@ -6251,7 +6120,7 @@
         </p:nvSpPr>
         <p:spPr>
           <a:xfrm>
-            <a:off x="3886200" y="1947672"/>
+            <a:off x="3977640" y="1947672"/>
             <a:ext cx="1828800" cy="457200"/>
           </a:xfrm>
           <a:prstGeom prst="rect">
@@ -6272,7 +6141,7 @@
                   <a:srgbClr val="C9A84C"/>
                 </a:solidFill>
               </a:rPr>
-              <a:t>Shawarma-Specific</a:t>
+              <a:t>ספציפי לשווארמה</a:t>
             </a:r>
           </a:p>
         </p:txBody>
@@ -6285,7 +6154,7 @@
         </p:nvSpPr>
         <p:spPr>
           <a:xfrm>
-            <a:off x="5760720" y="1920240"/>
+            <a:off x="5852160" y="1920240"/>
             <a:ext cx="1554480" cy="502920"/>
           </a:xfrm>
           <a:prstGeom prst="rect">
@@ -6328,7 +6197,7 @@
         </p:nvSpPr>
         <p:spPr>
           <a:xfrm>
-            <a:off x="5806440" y="1947672"/>
+            <a:off x="5897880" y="1947672"/>
             <a:ext cx="1463040" cy="457200"/>
           </a:xfrm>
           <a:prstGeom prst="rect">
@@ -6349,7 +6218,7 @@
                   <a:srgbClr val="C9A84C"/>
                 </a:solidFill>
               </a:rPr>
-              <a:t>Real-Time GPS</a:t>
+              <a:t>GPS בזמן אמת</a:t>
             </a:r>
           </a:p>
         </p:txBody>
@@ -6362,7 +6231,7 @@
         </p:nvSpPr>
         <p:spPr>
           <a:xfrm>
-            <a:off x="7315200" y="1920240"/>
+            <a:off x="7406640" y="1920240"/>
             <a:ext cx="1554480" cy="502920"/>
           </a:xfrm>
           <a:prstGeom prst="rect">
@@ -6405,7 +6274,7 @@
         </p:nvSpPr>
         <p:spPr>
           <a:xfrm>
-            <a:off x="7360920" y="1947672"/>
+            <a:off x="7452360" y="1947672"/>
             <a:ext cx="1463040" cy="457200"/>
           </a:xfrm>
           <a:prstGeom prst="rect">
@@ -6426,7 +6295,7 @@
                   <a:srgbClr val="C9A84C"/>
                 </a:solidFill>
               </a:rPr>
-              <a:t>ML Ranking</a:t>
+              <a:t>דירוג ML</a:t>
             </a:r>
           </a:p>
         </p:txBody>
@@ -6439,8 +6308,8 @@
         </p:nvSpPr>
         <p:spPr>
           <a:xfrm>
-            <a:off x="8869680" y="1920240"/>
-            <a:ext cx="2377440" cy="502920"/>
+            <a:off x="8961120" y="1920240"/>
+            <a:ext cx="2286000" cy="502920"/>
           </a:xfrm>
           <a:prstGeom prst="rect">
             <a:avLst/>
@@ -6482,8 +6351,8 @@
         </p:nvSpPr>
         <p:spPr>
           <a:xfrm>
-            <a:off x="8915400" y="1947672"/>
-            <a:ext cx="2286000" cy="457200"/>
+            <a:off x="9006840" y="1947672"/>
+            <a:ext cx="2194560" cy="457200"/>
           </a:xfrm>
           <a:prstGeom prst="rect">
             <a:avLst/>
@@ -6503,7 +6372,7 @@
                   <a:srgbClr val="C9A84C"/>
                 </a:solidFill>
               </a:rPr>
-              <a:t>Optimizes For</a:t>
+              <a:t>מייעל עבור</a:t>
             </a:r>
           </a:p>
         </p:txBody>
@@ -6560,7 +6429,7 @@
         <p:spPr>
           <a:xfrm>
             <a:off x="411480" y="2606040"/>
-            <a:ext cx="1828800" cy="457200"/>
+            <a:ext cx="1920240" cy="457200"/>
           </a:xfrm>
           <a:prstGeom prst="rect">
             <a:avLst/>
@@ -6580,7 +6449,7 @@
                   <a:srgbClr val="FFFFFF"/>
                 </a:solidFill>
               </a:rPr>
-              <a:t>Google Maps</a:t>
+              <a:t>גוגל מפות</a:t>
             </a:r>
           </a:p>
         </p:txBody>
@@ -6593,7 +6462,7 @@
         </p:nvSpPr>
         <p:spPr>
           <a:xfrm>
-            <a:off x="2331720" y="2606040"/>
+            <a:off x="2423160" y="2606040"/>
             <a:ext cx="1463040" cy="457200"/>
           </a:xfrm>
           <a:prstGeom prst="rect">
@@ -6627,7 +6496,7 @@
         </p:nvSpPr>
         <p:spPr>
           <a:xfrm>
-            <a:off x="3886200" y="2606040"/>
+            <a:off x="3977640" y="2606040"/>
             <a:ext cx="1828800" cy="457200"/>
           </a:xfrm>
           <a:prstGeom prst="rect">
@@ -6648,7 +6517,7 @@
                   <a:srgbClr val="FFFFFF"/>
                 </a:solidFill>
               </a:rPr>
-              <a:t>✗ (all food)</a:t>
+              <a:t>✗ (כל המזון)</a:t>
             </a:r>
           </a:p>
         </p:txBody>
@@ -6661,7 +6530,7 @@
         </p:nvSpPr>
         <p:spPr>
           <a:xfrm>
-            <a:off x="5806440" y="2606040"/>
+            <a:off x="5897880" y="2606040"/>
             <a:ext cx="1463040" cy="457200"/>
           </a:xfrm>
           <a:prstGeom prst="rect">
@@ -6695,7 +6564,7 @@
         </p:nvSpPr>
         <p:spPr>
           <a:xfrm>
-            <a:off x="7360920" y="2606040"/>
+            <a:off x="7452360" y="2606040"/>
             <a:ext cx="1463040" cy="457200"/>
           </a:xfrm>
           <a:prstGeom prst="rect">
@@ -6729,8 +6598,8 @@
         </p:nvSpPr>
         <p:spPr>
           <a:xfrm>
-            <a:off x="8915400" y="2606040"/>
-            <a:ext cx="2286000" cy="457200"/>
+            <a:off x="9006840" y="2606040"/>
+            <a:ext cx="2194560" cy="457200"/>
           </a:xfrm>
           <a:prstGeom prst="rect">
             <a:avLst/>
@@ -6750,7 +6619,7 @@
                   <a:srgbClr val="FFFFFF"/>
                 </a:solidFill>
               </a:rPr>
-              <a:t>Ad engagement</a:t>
+              <a:t>מעורבות פרסומות</a:t>
             </a:r>
           </a:p>
         </p:txBody>
@@ -6807,7 +6676,7 @@
         <p:spPr>
           <a:xfrm>
             <a:off x="411480" y="3264408"/>
-            <a:ext cx="1828800" cy="457200"/>
+            <a:ext cx="1920240" cy="457200"/>
           </a:xfrm>
           <a:prstGeom prst="rect">
             <a:avLst/>
@@ -6827,7 +6696,7 @@
                   <a:srgbClr val="FFFFFF"/>
                 </a:solidFill>
               </a:rPr>
-              <a:t>Wolt</a:t>
+              <a:t>וולט</a:t>
             </a:r>
           </a:p>
         </p:txBody>
@@ -6840,7 +6709,7 @@
         </p:nvSpPr>
         <p:spPr>
           <a:xfrm>
-            <a:off x="2331720" y="3264408"/>
+            <a:off x="2423160" y="3264408"/>
             <a:ext cx="1463040" cy="457200"/>
           </a:xfrm>
           <a:prstGeom prst="rect">
@@ -6874,7 +6743,7 @@
         </p:nvSpPr>
         <p:spPr>
           <a:xfrm>
-            <a:off x="3886200" y="3264408"/>
+            <a:off x="3977640" y="3264408"/>
             <a:ext cx="1828800" cy="457200"/>
           </a:xfrm>
           <a:prstGeom prst="rect">
@@ -6895,7 +6764,7 @@
                   <a:srgbClr val="FFFFFF"/>
                 </a:solidFill>
               </a:rPr>
-              <a:t>✗ (delivery)</a:t>
+              <a:t>✗ (משלוח)</a:t>
             </a:r>
           </a:p>
         </p:txBody>
@@ -6908,7 +6777,7 @@
         </p:nvSpPr>
         <p:spPr>
           <a:xfrm>
-            <a:off x="5806440" y="3264408"/>
+            <a:off x="5897880" y="3264408"/>
             <a:ext cx="1463040" cy="457200"/>
           </a:xfrm>
           <a:prstGeom prst="rect">
@@ -6942,7 +6811,7 @@
         </p:nvSpPr>
         <p:spPr>
           <a:xfrm>
-            <a:off x="7360920" y="3264408"/>
+            <a:off x="7452360" y="3264408"/>
             <a:ext cx="1463040" cy="457200"/>
           </a:xfrm>
           <a:prstGeom prst="rect">
@@ -6963,7 +6832,7 @@
                   <a:srgbClr val="FFFFFF"/>
                 </a:solidFill>
               </a:rPr>
-              <a:t>Delivery</a:t>
+              <a:t>משלוח</a:t>
             </a:r>
           </a:p>
         </p:txBody>
@@ -6976,8 +6845,8 @@
         </p:nvSpPr>
         <p:spPr>
           <a:xfrm>
-            <a:off x="8915400" y="3264408"/>
-            <a:ext cx="2286000" cy="457200"/>
+            <a:off x="9006840" y="3264408"/>
+            <a:ext cx="2194560" cy="457200"/>
           </a:xfrm>
           <a:prstGeom prst="rect">
             <a:avLst/>
@@ -6997,7 +6866,7 @@
                   <a:srgbClr val="FFFFFF"/>
                 </a:solidFill>
               </a:rPr>
-              <a:t>Commission</a:t>
+              <a:t>עמלת משלוח</a:t>
             </a:r>
           </a:p>
         </p:txBody>
@@ -7054,7 +6923,7 @@
         <p:spPr>
           <a:xfrm>
             <a:off x="411480" y="3922776"/>
-            <a:ext cx="1828800" cy="457200"/>
+            <a:ext cx="1920240" cy="457200"/>
           </a:xfrm>
           <a:prstGeom prst="rect">
             <a:avLst/>
@@ -7074,7 +6943,7 @@
                   <a:srgbClr val="FFFFFF"/>
                 </a:solidFill>
               </a:rPr>
-              <a:t>Ten Bis</a:t>
+              <a:t>תן ביס</a:t>
             </a:r>
           </a:p>
         </p:txBody>
@@ -7087,7 +6956,7 @@
         </p:nvSpPr>
         <p:spPr>
           <a:xfrm>
-            <a:off x="2331720" y="3922776"/>
+            <a:off x="2423160" y="3922776"/>
             <a:ext cx="1463040" cy="457200"/>
           </a:xfrm>
           <a:prstGeom prst="rect">
@@ -7121,7 +6990,7 @@
         </p:nvSpPr>
         <p:spPr>
           <a:xfrm>
-            <a:off x="3886200" y="3922776"/>
+            <a:off x="3977640" y="3922776"/>
             <a:ext cx="1828800" cy="457200"/>
           </a:xfrm>
           <a:prstGeom prst="rect">
@@ -7142,7 +7011,7 @@
                   <a:srgbClr val="FFFFFF"/>
                 </a:solidFill>
               </a:rPr>
-              <a:t>✗ (delivery)</a:t>
+              <a:t>✗ (משלוח)</a:t>
             </a:r>
           </a:p>
         </p:txBody>
@@ -7155,7 +7024,7 @@
         </p:nvSpPr>
         <p:spPr>
           <a:xfrm>
-            <a:off x="5806440" y="3922776"/>
+            <a:off x="5897880" y="3922776"/>
             <a:ext cx="1463040" cy="457200"/>
           </a:xfrm>
           <a:prstGeom prst="rect">
@@ -7189,7 +7058,7 @@
         </p:nvSpPr>
         <p:spPr>
           <a:xfrm>
-            <a:off x="7360920" y="3922776"/>
+            <a:off x="7452360" y="3922776"/>
             <a:ext cx="1463040" cy="457200"/>
           </a:xfrm>
           <a:prstGeom prst="rect">
@@ -7210,7 +7079,7 @@
                   <a:srgbClr val="FFFFFF"/>
                 </a:solidFill>
               </a:rPr>
-              <a:t>Delivery</a:t>
+              <a:t>משלוח</a:t>
             </a:r>
           </a:p>
         </p:txBody>
@@ -7223,8 +7092,8 @@
         </p:nvSpPr>
         <p:spPr>
           <a:xfrm>
-            <a:off x="8915400" y="3922776"/>
-            <a:ext cx="2286000" cy="457200"/>
+            <a:off x="9006840" y="3922776"/>
+            <a:ext cx="2194560" cy="457200"/>
           </a:xfrm>
           <a:prstGeom prst="rect">
             <a:avLst/>
@@ -7244,7 +7113,7 @@
                   <a:srgbClr val="FFFFFF"/>
                 </a:solidFill>
               </a:rPr>
-              <a:t>Commission</a:t>
+              <a:t>עמלת משלוח</a:t>
             </a:r>
           </a:p>
         </p:txBody>
@@ -7303,7 +7172,7 @@
         <p:spPr>
           <a:xfrm>
             <a:off x="411480" y="4581144"/>
-            <a:ext cx="1828800" cy="457200"/>
+            <a:ext cx="1920240" cy="457200"/>
           </a:xfrm>
           <a:prstGeom prst="rect">
             <a:avLst/>
@@ -7323,7 +7192,7 @@
                   <a:srgbClr val="F0D080"/>
                 </a:solidFill>
               </a:rPr>
-              <a:t>⭐ Appetite Engineering</a:t>
+              <a:t>⭐ הנדסת התיאבון</a:t>
             </a:r>
           </a:p>
         </p:txBody>
@@ -7336,7 +7205,7 @@
         </p:nvSpPr>
         <p:spPr>
           <a:xfrm>
-            <a:off x="2331720" y="4581144"/>
+            <a:off x="2423160" y="4581144"/>
             <a:ext cx="1463040" cy="457200"/>
           </a:xfrm>
           <a:prstGeom prst="rect">
@@ -7370,7 +7239,7 @@
         </p:nvSpPr>
         <p:spPr>
           <a:xfrm>
-            <a:off x="3886200" y="4581144"/>
+            <a:off x="3977640" y="4581144"/>
             <a:ext cx="1828800" cy="457200"/>
           </a:xfrm>
           <a:prstGeom prst="rect">
@@ -7391,7 +7260,7 @@
                   <a:srgbClr val="F0D080"/>
                 </a:solidFill>
               </a:rPr>
-              <a:t>✓ Shawarma only</a:t>
+              <a:t>✓ שווארמה בלבד</a:t>
             </a:r>
           </a:p>
         </p:txBody>
@@ -7404,7 +7273,7 @@
         </p:nvSpPr>
         <p:spPr>
           <a:xfrm>
-            <a:off x="5806440" y="4581144"/>
+            <a:off x="5897880" y="4581144"/>
             <a:ext cx="1463040" cy="457200"/>
           </a:xfrm>
           <a:prstGeom prst="rect">
@@ -7438,7 +7307,7 @@
         </p:nvSpPr>
         <p:spPr>
           <a:xfrm>
-            <a:off x="7360920" y="4581144"/>
+            <a:off x="7452360" y="4581144"/>
             <a:ext cx="1463040" cy="457200"/>
           </a:xfrm>
           <a:prstGeom prst="rect">
@@ -7472,8 +7341,8 @@
         </p:nvSpPr>
         <p:spPr>
           <a:xfrm>
-            <a:off x="8915400" y="4581144"/>
-            <a:ext cx="2286000" cy="457200"/>
+            <a:off x="9006840" y="4581144"/>
+            <a:ext cx="2194560" cy="457200"/>
           </a:xfrm>
           <a:prstGeom prst="rect">
             <a:avLst/>
@@ -7493,7 +7362,7 @@
                   <a:srgbClr val="F0D080"/>
                 </a:solidFill>
               </a:rPr>
-              <a:t>User value</a:t>
+              <a:t>ערך למשתמש</a:t>
             </a:r>
           </a:p>
         </p:txBody>
@@ -7507,7 +7376,7 @@
         <p:spPr>
           <a:xfrm>
             <a:off x="365760" y="5440680"/>
-            <a:ext cx="11457432" cy="1005840"/>
+            <a:ext cx="11457432" cy="1051560"/>
           </a:xfrm>
           <a:prstGeom prst="rect">
             <a:avLst/>
@@ -7551,7 +7420,7 @@
         </p:nvSpPr>
         <p:spPr>
           <a:xfrm>
-            <a:off x="548640" y="5532120"/>
+            <a:off x="8637195628800" y="5532120"/>
             <a:ext cx="2286000" cy="411480"/>
           </a:xfrm>
           <a:prstGeom prst="rect">
@@ -7565,14 +7434,14 @@
           </a:bodyPr>
           <a:lstStyle/>
           <a:p>
-            <a:pPr algn="l"/>
+            <a:pPr algn="r"/>
             <a:r>
               <a:rPr sz="1500" b="1" i="0">
                 <a:solidFill>
                   <a:srgbClr val="C9A84C"/>
                 </a:solidFill>
               </a:rPr>
-              <a:t>Our Differentiator:</a:t>
+              <a:t>:היתרון שלנו</a:t>
             </a:r>
           </a:p>
         </p:txBody>
@@ -7585,8 +7454,8 @@
         </p:nvSpPr>
         <p:spPr>
           <a:xfrm>
-            <a:off x="2834640" y="5532120"/>
-            <a:ext cx="8961120" cy="822960"/>
+            <a:off x="457200" y="5532120"/>
+            <a:ext cx="10881360" cy="822960"/>
           </a:xfrm>
           <a:prstGeom prst="rect">
             <a:avLst/>
@@ -7599,14 +7468,14 @@
           </a:bodyPr>
           <a:lstStyle/>
           <a:p>
-            <a:pPr algn="l"/>
+            <a:pPr algn="r"/>
             <a:r>
               <a:rPr sz="1300" b="0" i="0">
                 <a:solidFill>
                   <a:srgbClr val="FFFFFF"/>
                 </a:solidFill>
               </a:rPr>
-              <a:t>The only platform combining exact NIS prices + shawarma-only filtering + real-time geolocation + ML persona-free ranking — targeting the specific Israeli cultural value of the shawarma experience.</a:t>
+              <a:t>הפלטפורמה היחידה המשלבת מחירי ₪ מדויקים + סינון שווארמה בלבד + GPS בזמן אמת + דירוג ML — המכוונת לערך הישראלי של חוויית השווארמה.</a:t>
             </a:r>
           </a:p>
         </p:txBody>
@@ -7680,7 +7549,7 @@
         </p:nvSpPr>
         <p:spPr>
           <a:xfrm>
-            <a:off x="365760" y="182880"/>
+            <a:off x="9509760" y="182880"/>
             <a:ext cx="2286000" cy="502920"/>
           </a:xfrm>
           <a:prstGeom prst="rect">
@@ -7725,7 +7594,7 @@
         </p:nvSpPr>
         <p:spPr>
           <a:xfrm>
-            <a:off x="365760" y="182880"/>
+            <a:off x="9509760" y="182880"/>
             <a:ext cx="2286000" cy="502920"/>
           </a:xfrm>
           <a:prstGeom prst="rect">
@@ -7759,7 +7628,7 @@
         </p:nvSpPr>
         <p:spPr>
           <a:xfrm>
-            <a:off x="2834640" y="228600"/>
+            <a:off x="365760" y="228600"/>
             <a:ext cx="8961120" cy="411480"/>
           </a:xfrm>
           <a:prstGeom prst="rect">
@@ -7773,14 +7642,14 @@
           </a:bodyPr>
           <a:lstStyle/>
           <a:p>
-            <a:pPr algn="l"/>
+            <a:pPr algn="r"/>
             <a:r>
               <a:rPr sz="1200" b="0" i="0">
                 <a:solidFill>
                   <a:srgbClr val="8B8B8B"/>
                 </a:solidFill>
               </a:rPr>
-              <a:t>Section 3 / 4</a:t>
+              <a:t>חלק 3 מתוך 4</a:t>
             </a:r>
           </a:p>
         </p:txBody>
@@ -7807,14 +7676,14 @@
           </a:bodyPr>
           <a:lstStyle/>
           <a:p>
-            <a:pPr algn="l"/>
+            <a:pPr algn="r"/>
             <a:r>
               <a:rPr sz="3000" b="1" i="0">
                 <a:solidFill>
                   <a:srgbClr val="F0D080"/>
                 </a:solidFill>
               </a:rPr>
-              <a:t>EDA &amp; Data Insights — What the Data Shows</a:t>
+              <a:t>ניתוח נתוני EDA — מה הנתונים מראים</a:t>
             </a:r>
           </a:p>
         </p:txBody>
@@ -7970,7 +7839,7 @@
                   <a:srgbClr val="FFFFFF"/>
                 </a:solidFill>
               </a:rPr>
-              <a:t>Venues</a:t>
+              <a:t>מסעדות</a:t>
             </a:r>
           </a:p>
         </p:txBody>
@@ -8004,7 +7873,7 @@
                   <a:srgbClr val="8B8B8B"/>
                 </a:solidFill>
               </a:rPr>
-              <a:t>after deduplication</a:t>
+              <a:t>אחרי ניקוי כפילויות</a:t>
             </a:r>
           </a:p>
         </p:txBody>
@@ -8117,7 +7986,7 @@
                   <a:srgbClr val="FFFFFF"/>
                 </a:solidFill>
               </a:rPr>
-              <a:t>Cities</a:t>
+              <a:t>ערים</a:t>
             </a:r>
           </a:p>
         </p:txBody>
@@ -8151,7 +8020,7 @@
                   <a:srgbClr val="8B8B8B"/>
                 </a:solidFill>
               </a:rPr>
-              <a:t>across Israel</a:t>
+              <a:t>ברחבי ישראל</a:t>
             </a:r>
           </a:p>
         </p:txBody>
@@ -8264,7 +8133,7 @@
                   <a:srgbClr val="FFFFFF"/>
                 </a:solidFill>
               </a:rPr>
-              <a:t>Median price</a:t>
+              <a:t>מחיר חציוני</a:t>
             </a:r>
           </a:p>
         </p:txBody>
@@ -8298,7 +8167,7 @@
                   <a:srgbClr val="8B8B8B"/>
                 </a:solidFill>
               </a:rPr>
-              <a:t>Turkey shawarma pita</a:t>
+              <a:t>פיתה טורקי</a:t>
             </a:r>
           </a:p>
         </p:txBody>
@@ -8411,7 +8280,7 @@
                   <a:srgbClr val="FFFFFF"/>
                 </a:solidFill>
               </a:rPr>
-              <a:t>Avg rating</a:t>
+              <a:t>דירוג ממוצע</a:t>
             </a:r>
           </a:p>
         </p:txBody>
@@ -8445,7 +8314,7 @@
                   <a:srgbClr val="8B8B8B"/>
                 </a:solidFill>
               </a:rPr>
-              <a:t>across all venues</a:t>
+              <a:t>בין כל המסעדות</a:t>
             </a:r>
           </a:p>
         </p:txBody>
@@ -8558,7 +8427,7 @@
                   <a:srgbClr val="FFFFFF"/>
                 </a:solidFill>
               </a:rPr>
-              <a:t>Price↔Quality</a:t>
+              <a:t>מחיר↔איכות</a:t>
             </a:r>
           </a:p>
         </p:txBody>
@@ -8592,7 +8461,7 @@
                   <a:srgbClr val="8B8B8B"/>
                 </a:solidFill>
               </a:rPr>
-              <a:t>no correlation</a:t>
+              <a:t>כמעט אין קורלציה</a:t>
             </a:r>
           </a:p>
         </p:txBody>
@@ -8664,14 +8533,14 @@
           </a:bodyPr>
           <a:lstStyle/>
           <a:p>
-            <a:pPr algn="l"/>
+            <a:pPr algn="r"/>
             <a:r>
               <a:rPr sz="1300" b="1" i="0">
                 <a:solidFill>
                   <a:srgbClr val="C9A84C"/>
                 </a:solidFill>
               </a:rPr>
-              <a:t>Price vs. Rating — The Chaos (r = −0.06)</a:t>
+              <a:t>מחיר מול דירוג — הכאוס (r = −0.06)</a:t>
             </a:r>
           </a:p>
         </p:txBody>
@@ -8684,8 +8553,8 @@
         </p:nvSpPr>
         <p:spPr>
           <a:xfrm>
-            <a:off x="384048" y="3657600"/>
-            <a:ext cx="548640" cy="2286000"/>
+            <a:off x="384048" y="3749039"/>
+            <a:ext cx="502920" cy="2103120"/>
           </a:xfrm>
           <a:prstGeom prst="rect">
             <a:avLst/>
@@ -8698,14 +8567,14 @@
           </a:bodyPr>
           <a:lstStyle/>
           <a:p>
-            <a:pPr algn="l"/>
+            <a:pPr algn="ctr"/>
             <a:r>
               <a:rPr sz="1000" b="0" i="0">
                 <a:solidFill>
                   <a:srgbClr val="8B8B8B"/>
                 </a:solidFill>
               </a:rPr>
-              <a:t>Rating ↑</a:t>
+              <a:t>דירוג ↑</a:t>
             </a:r>
           </a:p>
         </p:txBody>
@@ -8718,7 +8587,7 @@
         </p:nvSpPr>
         <p:spPr>
           <a:xfrm>
-            <a:off x="1097280" y="6217920"/>
+            <a:off x="1097280" y="6236208"/>
             <a:ext cx="3657600" cy="274320"/>
           </a:xfrm>
           <a:prstGeom prst="rect">
@@ -8732,14 +8601,14 @@
           </a:bodyPr>
           <a:lstStyle/>
           <a:p>
-            <a:pPr algn="l"/>
+            <a:pPr algn="r"/>
             <a:r>
               <a:rPr sz="1000" b="0" i="0">
                 <a:solidFill>
                   <a:srgbClr val="8B8B8B"/>
                 </a:solidFill>
               </a:rPr>
-              <a:t>Price (₪) →</a:t>
+              <a:t>← מחיר (₪)</a:t>
             </a:r>
           </a:p>
         </p:txBody>
@@ -8752,7 +8621,7 @@
         </p:nvSpPr>
         <p:spPr>
           <a:xfrm>
-            <a:off x="3591233" y="3626765"/>
+            <a:off x="3591233" y="3671341"/>
             <a:ext cx="60351" cy="60351"/>
           </a:xfrm>
           <a:prstGeom prst="rect">
@@ -8795,7 +8664,7 @@
         </p:nvSpPr>
         <p:spPr>
           <a:xfrm>
-            <a:off x="1534290" y="3814522"/>
+            <a:off x="1534290" y="3855556"/>
             <a:ext cx="77382" cy="77382"/>
           </a:xfrm>
           <a:prstGeom prst="rect">
@@ -8838,7 +8707,7 @@
         </p:nvSpPr>
         <p:spPr>
           <a:xfrm>
-            <a:off x="1317855" y="4588544"/>
+            <a:off x="1317855" y="4614973"/>
             <a:ext cx="51381" cy="51381"/>
           </a:xfrm>
           <a:prstGeom prst="rect">
@@ -8881,7 +8750,7 @@
         </p:nvSpPr>
         <p:spPr>
           <a:xfrm>
-            <a:off x="1917473" y="5024947"/>
+            <a:off x="1917473" y="5043143"/>
             <a:ext cx="70820" cy="70820"/>
           </a:xfrm>
           <a:prstGeom prst="rect">
@@ -8924,7 +8793,7 @@
         </p:nvSpPr>
         <p:spPr>
           <a:xfrm>
-            <a:off x="3634264" y="4886640"/>
+            <a:off x="3634264" y="4907445"/>
             <a:ext cx="58354" cy="58354"/>
           </a:xfrm>
           <a:prstGeom prst="rect">
@@ -8967,7 +8836,7 @@
         </p:nvSpPr>
         <p:spPr>
           <a:xfrm>
-            <a:off x="2104819" y="5672613"/>
+            <a:off x="2104819" y="5678589"/>
             <a:ext cx="78046" cy="78046"/>
           </a:xfrm>
           <a:prstGeom prst="rect">
@@ -9010,7 +8879,7 @@
         </p:nvSpPr>
         <p:spPr>
           <a:xfrm>
-            <a:off x="3832823" y="4390641"/>
+            <a:off x="3832823" y="4420805"/>
             <a:ext cx="55978" cy="55978"/>
           </a:xfrm>
           <a:prstGeom prst="rect">
@@ -9053,7 +8922,7 @@
         </p:nvSpPr>
         <p:spPr>
           <a:xfrm>
-            <a:off x="1380694" y="4486784"/>
+            <a:off x="1380694" y="4515134"/>
             <a:ext cx="63422" cy="63422"/>
           </a:xfrm>
           <a:prstGeom prst="rect">
@@ -9096,7 +8965,7 @@
         </p:nvSpPr>
         <p:spPr>
           <a:xfrm>
-            <a:off x="3444331" y="5521960"/>
+            <a:off x="3444331" y="5530779"/>
             <a:ext cx="76982" cy="76982"/>
           </a:xfrm>
           <a:prstGeom prst="rect">
@@ -9139,7 +9008,7 @@
         </p:nvSpPr>
         <p:spPr>
           <a:xfrm>
-            <a:off x="1473754" y="5801029"/>
+            <a:off x="1473754" y="5804581"/>
             <a:ext cx="53174" cy="53174"/>
           </a:xfrm>
           <a:prstGeom prst="rect">
@@ -9182,7 +9051,7 @@
         </p:nvSpPr>
         <p:spPr>
           <a:xfrm>
-            <a:off x="4372954" y="5064932"/>
+            <a:off x="4372954" y="5082373"/>
             <a:ext cx="81809" cy="81809"/>
           </a:xfrm>
           <a:prstGeom prst="rect">
@@ -9225,7 +9094,7 @@
         </p:nvSpPr>
         <p:spPr>
           <a:xfrm>
-            <a:off x="1751349" y="3734703"/>
+            <a:off x="1751349" y="3777243"/>
             <a:ext cx="74478" cy="74478"/>
           </a:xfrm>
           <a:prstGeom prst="rect">
@@ -9268,7 +9137,7 @@
         </p:nvSpPr>
         <p:spPr>
           <a:xfrm>
-            <a:off x="5014109" y="5638731"/>
+            <a:off x="5014109" y="5645346"/>
             <a:ext cx="81984" cy="81984"/>
           </a:xfrm>
           <a:prstGeom prst="rect">
@@ -9311,7 +9180,7 @@
         </p:nvSpPr>
         <p:spPr>
           <a:xfrm>
-            <a:off x="2103925" y="5106525"/>
+            <a:off x="2103925" y="5123181"/>
             <a:ext cx="63636" cy="63636"/>
           </a:xfrm>
           <a:prstGeom prst="rect">
@@ -9354,7 +9223,7 @@
         </p:nvSpPr>
         <p:spPr>
           <a:xfrm>
-            <a:off x="2421987" y="5190101"/>
+            <a:off x="2421987" y="5205181"/>
             <a:ext cx="75961" cy="75961"/>
           </a:xfrm>
           <a:prstGeom prst="rect">
@@ -9397,7 +9266,7 @@
         </p:nvSpPr>
         <p:spPr>
           <a:xfrm>
-            <a:off x="3626656" y="5042181"/>
+            <a:off x="3626656" y="5060052"/>
             <a:ext cx="56551" cy="56551"/>
           </a:xfrm>
           <a:prstGeom prst="rect">
@@ -9440,7 +9309,7 @@
         </p:nvSpPr>
         <p:spPr>
           <a:xfrm>
-            <a:off x="1967467" y="4686290"/>
+            <a:off x="1967467" y="4710875"/>
             <a:ext cx="60165" cy="60165"/>
           </a:xfrm>
           <a:prstGeom prst="rect">
@@ -9483,7 +9352,7 @@
         </p:nvSpPr>
         <p:spPr>
           <a:xfrm>
-            <a:off x="3791768" y="4098322"/>
+            <a:off x="3791768" y="4134001"/>
             <a:ext cx="62152" cy="62152"/>
           </a:xfrm>
           <a:prstGeom prst="rect">
@@ -9526,7 +9395,7 @@
         </p:nvSpPr>
         <p:spPr>
           <a:xfrm>
-            <a:off x="1902607" y="3643944"/>
+            <a:off x="1902607" y="3688196"/>
             <a:ext cx="61830" cy="61830"/>
           </a:xfrm>
           <a:prstGeom prst="rect">
@@ -9569,7 +9438,7 @@
         </p:nvSpPr>
         <p:spPr>
           <a:xfrm>
-            <a:off x="1232472" y="5778834"/>
+            <a:off x="1232472" y="5782806"/>
             <a:ext cx="71037" cy="71037"/>
           </a:xfrm>
           <a:prstGeom prst="rect">
@@ -9612,7 +9481,7 @@
         </p:nvSpPr>
         <p:spPr>
           <a:xfrm>
-            <a:off x="2254956" y="5154392"/>
+            <a:off x="2254956" y="5170146"/>
             <a:ext cx="64762" cy="64762"/>
           </a:xfrm>
           <a:prstGeom prst="rect">
@@ -9655,7 +9524,7 @@
         </p:nvSpPr>
         <p:spPr>
           <a:xfrm>
-            <a:off x="2848203" y="4208007"/>
+            <a:off x="2848203" y="4241616"/>
             <a:ext cx="59312" cy="59312"/>
           </a:xfrm>
           <a:prstGeom prst="rect">
@@ -9698,7 +9567,7 @@
         </p:nvSpPr>
         <p:spPr>
           <a:xfrm>
-            <a:off x="3177903" y="5376293"/>
+            <a:off x="3177903" y="5387860"/>
             <a:ext cx="65962" cy="65962"/>
           </a:xfrm>
           <a:prstGeom prst="rect">
@@ -9741,7 +9610,7 @@
         </p:nvSpPr>
         <p:spPr>
           <a:xfrm>
-            <a:off x="2603573" y="4097609"/>
+            <a:off x="2603573" y="4133301"/>
             <a:ext cx="86777" cy="86777"/>
           </a:xfrm>
           <a:prstGeom prst="rect">
@@ -9784,7 +9653,7 @@
         </p:nvSpPr>
         <p:spPr>
           <a:xfrm>
-            <a:off x="2990838" y="5397541"/>
+            <a:off x="2990838" y="5408706"/>
             <a:ext cx="81787" cy="81787"/>
           </a:xfrm>
           <a:prstGeom prst="rect">
@@ -9827,7 +9696,7 @@
         </p:nvSpPr>
         <p:spPr>
           <a:xfrm>
-            <a:off x="3541934" y="5485495"/>
+            <a:off x="3541934" y="5495001"/>
             <a:ext cx="65732" cy="65732"/>
           </a:xfrm>
           <a:prstGeom prst="rect">
@@ -9870,7 +9739,7 @@
         </p:nvSpPr>
         <p:spPr>
           <a:xfrm>
-            <a:off x="2543360" y="5010093"/>
+            <a:off x="2543360" y="5028568"/>
             <a:ext cx="67411" cy="67411"/>
           </a:xfrm>
           <a:prstGeom prst="rect">
@@ -9913,7 +9782,7 @@
         </p:nvSpPr>
         <p:spPr>
           <a:xfrm>
-            <a:off x="4955913" y="5651966"/>
+            <a:off x="4955913" y="5658332"/>
             <a:ext cx="50711" cy="50711"/>
           </a:xfrm>
           <a:prstGeom prst="rect">
@@ -9956,7 +9825,7 @@
         </p:nvSpPr>
         <p:spPr>
           <a:xfrm>
-            <a:off x="1431477" y="5710143"/>
+            <a:off x="1431477" y="5715411"/>
             <a:ext cx="77756" cy="77756"/>
           </a:xfrm>
           <a:prstGeom prst="rect">
@@ -9999,7 +9868,7 @@
         </p:nvSpPr>
         <p:spPr>
           <a:xfrm>
-            <a:off x="2359874" y="4277357"/>
+            <a:off x="2359874" y="4309658"/>
             <a:ext cx="56076" cy="56076"/>
           </a:xfrm>
           <a:prstGeom prst="rect">
@@ -10042,7 +9911,7 @@
         </p:nvSpPr>
         <p:spPr>
           <a:xfrm>
-            <a:off x="4884881" y="5688491"/>
+            <a:off x="4884881" y="5694167"/>
             <a:ext cx="59925" cy="59925"/>
           </a:xfrm>
           <a:prstGeom prst="rect">
@@ -10085,7 +9954,7 @@
         </p:nvSpPr>
         <p:spPr>
           <a:xfrm>
-            <a:off x="4095442" y="4796353"/>
+            <a:off x="4095442" y="4818862"/>
             <a:ext cx="54184" cy="54184"/>
           </a:xfrm>
           <a:prstGeom prst="rect">
@@ -10128,7 +9997,7 @@
         </p:nvSpPr>
         <p:spPr>
           <a:xfrm>
-            <a:off x="2188160" y="5114436"/>
+            <a:off x="2188160" y="5130944"/>
             <a:ext cx="72565" cy="72565"/>
           </a:xfrm>
           <a:prstGeom prst="rect">
@@ -10171,7 +10040,7 @@
         </p:nvSpPr>
         <p:spPr>
           <a:xfrm>
-            <a:off x="2498700" y="3957619"/>
+            <a:off x="2498700" y="3995953"/>
             <a:ext cx="85167" cy="85167"/>
           </a:xfrm>
           <a:prstGeom prst="rect">
@@ -10214,7 +10083,7 @@
         </p:nvSpPr>
         <p:spPr>
           <a:xfrm>
-            <a:off x="4739537" y="5017498"/>
+            <a:off x="4739537" y="5035834"/>
             <a:ext cx="68163" cy="68163"/>
           </a:xfrm>
           <a:prstGeom prst="rect">
@@ -10257,7 +10126,7 @@
         </p:nvSpPr>
         <p:spPr>
           <a:xfrm>
-            <a:off x="4783174" y="5695443"/>
+            <a:off x="4783174" y="5700988"/>
             <a:ext cx="80710" cy="80710"/>
           </a:xfrm>
           <a:prstGeom prst="rect">
@@ -10300,7 +10169,7 @@
         </p:nvSpPr>
         <p:spPr>
           <a:xfrm>
-            <a:off x="1945418" y="4149830"/>
+            <a:off x="1945418" y="4184537"/>
             <a:ext cx="71043" cy="71043"/>
           </a:xfrm>
           <a:prstGeom prst="rect">
@@ -10343,7 +10212,7 @@
         </p:nvSpPr>
         <p:spPr>
           <a:xfrm>
-            <a:off x="1312566" y="4743792"/>
+            <a:off x="1312566" y="4767293"/>
             <a:ext cx="52823" cy="52823"/>
           </a:xfrm>
           <a:prstGeom prst="rect">
@@ -10386,7 +10255,7 @@
         </p:nvSpPr>
         <p:spPr>
           <a:xfrm>
-            <a:off x="4111375" y="3877273"/>
+            <a:off x="4111375" y="3917123"/>
             <a:ext cx="67675" cy="67675"/>
           </a:xfrm>
           <a:prstGeom prst="rect">
@@ -10429,7 +10298,7 @@
         </p:nvSpPr>
         <p:spPr>
           <a:xfrm>
-            <a:off x="1639584" y="4844798"/>
+            <a:off x="1639584" y="4866392"/>
             <a:ext cx="72478" cy="72478"/>
           </a:xfrm>
           <a:prstGeom prst="rect">
@@ -10472,7 +10341,7 @@
         </p:nvSpPr>
         <p:spPr>
           <a:xfrm>
-            <a:off x="4782413" y="5396288"/>
+            <a:off x="4782413" y="5407477"/>
             <a:ext cx="75524" cy="75524"/>
           </a:xfrm>
           <a:prstGeom prst="rect">
@@ -10515,7 +10384,7 @@
         </p:nvSpPr>
         <p:spPr>
           <a:xfrm>
-            <a:off x="2242770" y="5977566"/>
+            <a:off x="2242770" y="5977787"/>
             <a:ext cx="74061" cy="74061"/>
           </a:xfrm>
           <a:prstGeom prst="rect">
@@ -10558,7 +10427,7 @@
         </p:nvSpPr>
         <p:spPr>
           <a:xfrm>
-            <a:off x="4661852" y="4660183"/>
+            <a:off x="4661852" y="4685261"/>
             <a:ext cx="59359" cy="59359"/>
           </a:xfrm>
           <a:prstGeom prst="rect">
@@ -10601,7 +10470,7 @@
         </p:nvSpPr>
         <p:spPr>
           <a:xfrm>
-            <a:off x="2351274" y="4991726"/>
+            <a:off x="2351274" y="5010548"/>
             <a:ext cx="58708" cy="58708"/>
           </a:xfrm>
           <a:prstGeom prst="rect">
@@ -10644,7 +10513,7 @@
         </p:nvSpPr>
         <p:spPr>
           <a:xfrm>
-            <a:off x="989708" y="5281371"/>
+            <a:off x="989708" y="5294729"/>
             <a:ext cx="52445" cy="52445"/>
           </a:xfrm>
           <a:prstGeom prst="rect">
@@ -10687,7 +10556,7 @@
         </p:nvSpPr>
         <p:spPr>
           <a:xfrm>
-            <a:off x="4685742" y="5649194"/>
+            <a:off x="4685742" y="5655611"/>
             <a:ext cx="52883" cy="52883"/>
           </a:xfrm>
           <a:prstGeom prst="rect">
@@ -10730,7 +10599,7 @@
         </p:nvSpPr>
         <p:spPr>
           <a:xfrm>
-            <a:off x="2105998" y="4742396"/>
+            <a:off x="2105998" y="4765923"/>
             <a:ext cx="70015" cy="70015"/>
           </a:xfrm>
           <a:prstGeom prst="rect">
@@ -10773,7 +10642,7 @@
         </p:nvSpPr>
         <p:spPr>
           <a:xfrm>
-            <a:off x="4809573" y="4949888"/>
+            <a:off x="4809573" y="4969500"/>
             <a:ext cx="67580" cy="67580"/>
           </a:xfrm>
           <a:prstGeom prst="rect">
@@ -10816,7 +10685,7 @@
         </p:nvSpPr>
         <p:spPr>
           <a:xfrm>
-            <a:off x="4282808" y="4027553"/>
+            <a:off x="4282808" y="4064568"/>
             <a:ext cx="53837" cy="53837"/>
           </a:xfrm>
           <a:prstGeom prst="rect">
@@ -10859,7 +10728,7 @@
         </p:nvSpPr>
         <p:spPr>
           <a:xfrm>
-            <a:off x="2417983" y="4562326"/>
+            <a:off x="2417983" y="4589250"/>
             <a:ext cx="81887" cy="81887"/>
           </a:xfrm>
           <a:prstGeom prst="rect">
@@ -10902,7 +10771,7 @@
         </p:nvSpPr>
         <p:spPr>
           <a:xfrm>
-            <a:off x="3730880" y="5950949"/>
+            <a:off x="3730880" y="5951673"/>
             <a:ext cx="53891" cy="53891"/>
           </a:xfrm>
           <a:prstGeom prst="rect">
@@ -10945,7 +10814,7 @@
         </p:nvSpPr>
         <p:spPr>
           <a:xfrm>
-            <a:off x="3956573" y="5506123"/>
+            <a:off x="3956573" y="5515240"/>
             <a:ext cx="54288" cy="54288"/>
           </a:xfrm>
           <a:prstGeom prst="rect">
@@ -10988,7 +10857,7 @@
         </p:nvSpPr>
         <p:spPr>
           <a:xfrm>
-            <a:off x="1742791" y="4653222"/>
+            <a:off x="1742791" y="4678431"/>
             <a:ext cx="65722" cy="65722"/>
           </a:xfrm>
           <a:prstGeom prst="rect">
@@ -11031,7 +10900,7 @@
         </p:nvSpPr>
         <p:spPr>
           <a:xfrm>
-            <a:off x="2863741" y="5685179"/>
+            <a:off x="2863741" y="5690917"/>
             <a:ext cx="53049" cy="53049"/>
           </a:xfrm>
           <a:prstGeom prst="rect">
@@ -11074,7 +10943,7 @@
         </p:nvSpPr>
         <p:spPr>
           <a:xfrm>
-            <a:off x="1362994" y="5146411"/>
+            <a:off x="1362994" y="5162315"/>
             <a:ext cx="70064" cy="70064"/>
           </a:xfrm>
           <a:prstGeom prst="rect">
@@ -11117,7 +10986,7 @@
         </p:nvSpPr>
         <p:spPr>
           <a:xfrm>
-            <a:off x="4947345" y="5810895"/>
+            <a:off x="4947345" y="5814261"/>
             <a:ext cx="81333" cy="81333"/>
           </a:xfrm>
           <a:prstGeom prst="rect">
@@ -11160,7 +11029,7 @@
         </p:nvSpPr>
         <p:spPr>
           <a:xfrm>
-            <a:off x="2632432" y="4732568"/>
+            <a:off x="2632432" y="4756280"/>
             <a:ext cx="81917" cy="81917"/>
           </a:xfrm>
           <a:prstGeom prst="rect">
@@ -11203,7 +11072,7 @@
         </p:nvSpPr>
         <p:spPr>
           <a:xfrm>
-            <a:off x="1637568" y="3571382"/>
+            <a:off x="1637568" y="3617004"/>
             <a:ext cx="64572" cy="64572"/>
           </a:xfrm>
           <a:prstGeom prst="rect">
@@ -11246,7 +11115,7 @@
         </p:nvSpPr>
         <p:spPr>
           <a:xfrm>
-            <a:off x="2133863" y="5254112"/>
+            <a:off x="2133863" y="5267984"/>
             <a:ext cx="77010" cy="77010"/>
           </a:xfrm>
           <a:prstGeom prst="rect">
@@ -11289,7 +11158,7 @@
         </p:nvSpPr>
         <p:spPr>
           <a:xfrm>
-            <a:off x="3683588" y="4745442"/>
+            <a:off x="3683588" y="4768912"/>
             <a:ext cx="57237" cy="57237"/>
           </a:xfrm>
           <a:prstGeom prst="rect">
@@ -11332,7 +11201,7 @@
         </p:nvSpPr>
         <p:spPr>
           <a:xfrm>
-            <a:off x="4946165" y="4969606"/>
+            <a:off x="4946165" y="4988846"/>
             <a:ext cx="70123" cy="70123"/>
           </a:xfrm>
           <a:prstGeom prst="rect">
@@ -11375,7 +11244,7 @@
         </p:nvSpPr>
         <p:spPr>
           <a:xfrm>
-            <a:off x="2250541" y="3687662"/>
+            <a:off x="2250541" y="3731090"/>
             <a:ext cx="67731" cy="67731"/>
           </a:xfrm>
           <a:prstGeom prst="rect">
@@ -11418,7 +11287,7 @@
         </p:nvSpPr>
         <p:spPr>
           <a:xfrm>
-            <a:off x="1607924" y="5894281"/>
+            <a:off x="1607924" y="5896074"/>
             <a:ext cx="53222" cy="53222"/>
           </a:xfrm>
           <a:prstGeom prst="rect">
@@ -11461,7 +11330,7 @@
         </p:nvSpPr>
         <p:spPr>
           <a:xfrm>
-            <a:off x="1242071" y="3730840"/>
+            <a:off x="1242071" y="3773452"/>
             <a:ext cx="81813" cy="81813"/>
           </a:xfrm>
           <a:prstGeom prst="rect">
@@ -11504,7 +11373,7 @@
         </p:nvSpPr>
         <p:spPr>
           <a:xfrm>
-            <a:off x="1453429" y="5723468"/>
+            <a:off x="1453429" y="5728484"/>
             <a:ext cx="59297" cy="59297"/>
           </a:xfrm>
           <a:prstGeom prst="rect">
@@ -11547,7 +11416,7 @@
         </p:nvSpPr>
         <p:spPr>
           <a:xfrm>
-            <a:off x="1123648" y="3764818"/>
+            <a:off x="1123648" y="3806790"/>
             <a:ext cx="74336" cy="74336"/>
           </a:xfrm>
           <a:prstGeom prst="rect">
@@ -11590,7 +11459,7 @@
         </p:nvSpPr>
         <p:spPr>
           <a:xfrm>
-            <a:off x="3111266" y="5831102"/>
+            <a:off x="3111266" y="5834088"/>
             <a:ext cx="57762" cy="57762"/>
           </a:xfrm>
           <a:prstGeom prst="rect">
@@ -11633,7 +11502,7 @@
         </p:nvSpPr>
         <p:spPr>
           <a:xfrm>
-            <a:off x="2252923" y="4209786"/>
+            <a:off x="2252923" y="4243362"/>
             <a:ext cx="55079" cy="55079"/>
           </a:xfrm>
           <a:prstGeom prst="rect">
@@ -11676,7 +11545,7 @@
         </p:nvSpPr>
         <p:spPr>
           <a:xfrm>
-            <a:off x="2194547" y="4332307"/>
+            <a:off x="2194547" y="4363572"/>
             <a:ext cx="77792" cy="77792"/>
           </a:xfrm>
           <a:prstGeom prst="rect">
@@ -11719,7 +11588,7 @@
         </p:nvSpPr>
         <p:spPr>
           <a:xfrm>
-            <a:off x="998451" y="5071328"/>
+            <a:off x="998451" y="5088648"/>
             <a:ext cx="70884" cy="70884"/>
           </a:xfrm>
           <a:prstGeom prst="rect">
@@ -11762,7 +11631,7 @@
         </p:nvSpPr>
         <p:spPr>
           <a:xfrm>
-            <a:off x="1261573" y="4082667"/>
+            <a:off x="1261573" y="4118641"/>
             <a:ext cx="59991" cy="59991"/>
           </a:xfrm>
           <a:prstGeom prst="rect">
@@ -11805,7 +11674,7 @@
         </p:nvSpPr>
         <p:spPr>
           <a:xfrm>
-            <a:off x="4584699" y="5696772"/>
+            <a:off x="4584699" y="5702292"/>
             <a:ext cx="63807" cy="63807"/>
           </a:xfrm>
           <a:prstGeom prst="rect">
@@ -11848,7 +11717,7 @@
         </p:nvSpPr>
         <p:spPr>
           <a:xfrm>
-            <a:off x="2763161" y="4882464"/>
+            <a:off x="2763161" y="4903348"/>
             <a:ext cx="61356" cy="61356"/>
           </a:xfrm>
           <a:prstGeom prst="rect">
@@ -11891,7 +11760,7 @@
         </p:nvSpPr>
         <p:spPr>
           <a:xfrm>
-            <a:off x="3136605" y="5184499"/>
+            <a:off x="3136605" y="5199684"/>
             <a:ext cx="70577" cy="70577"/>
           </a:xfrm>
           <a:prstGeom prst="rect">
@@ -11934,7 +11803,7 @@
         </p:nvSpPr>
         <p:spPr>
           <a:xfrm>
-            <a:off x="1386357" y="5694002"/>
+            <a:off x="1386357" y="5699574"/>
             <a:ext cx="59965" cy="59965"/>
           </a:xfrm>
           <a:prstGeom prst="rect">
@@ -11977,7 +11846,7 @@
         </p:nvSpPr>
         <p:spPr>
           <a:xfrm>
-            <a:off x="4015016" y="3942835"/>
+            <a:off x="4015016" y="3981448"/>
             <a:ext cx="60597" cy="60597"/>
           </a:xfrm>
           <a:prstGeom prst="rect">
@@ -12020,7 +11889,7 @@
         </p:nvSpPr>
         <p:spPr>
           <a:xfrm>
-            <a:off x="3912950" y="4059508"/>
+            <a:off x="3912950" y="4095920"/>
             <a:ext cx="73489" cy="73489"/>
           </a:xfrm>
           <a:prstGeom prst="rect">
@@ -12063,7 +11932,7 @@
         </p:nvSpPr>
         <p:spPr>
           <a:xfrm>
-            <a:off x="3039777" y="4174666"/>
+            <a:off x="3039777" y="4208905"/>
             <a:ext cx="83508" cy="83508"/>
           </a:xfrm>
           <a:prstGeom prst="rect">
@@ -12106,7 +11975,7 @@
         </p:nvSpPr>
         <p:spPr>
           <a:xfrm>
-            <a:off x="1339909" y="4592551"/>
+            <a:off x="1339909" y="4618905"/>
             <a:ext cx="60411" cy="60411"/>
           </a:xfrm>
           <a:prstGeom prst="rect">
@@ -12149,7 +12018,7 @@
         </p:nvSpPr>
         <p:spPr>
           <a:xfrm>
-            <a:off x="2332638" y="3883156"/>
+            <a:off x="2332638" y="3922895"/>
             <a:ext cx="86129" cy="86129"/>
           </a:xfrm>
           <a:prstGeom prst="rect">
@@ -12192,7 +12061,7 @@
         </p:nvSpPr>
         <p:spPr>
           <a:xfrm>
-            <a:off x="4010136" y="4902969"/>
+            <a:off x="4010136" y="4923467"/>
             <a:ext cx="65935" cy="65935"/>
           </a:xfrm>
           <a:prstGeom prst="rect">
@@ -12235,7 +12104,7 @@
         </p:nvSpPr>
         <p:spPr>
           <a:xfrm>
-            <a:off x="1420458" y="5856169"/>
+            <a:off x="1420458" y="5858681"/>
             <a:ext cx="75566" cy="75566"/>
           </a:xfrm>
           <a:prstGeom prst="rect">
@@ -12278,7 +12147,7 @@
         </p:nvSpPr>
         <p:spPr>
           <a:xfrm>
-            <a:off x="3205114" y="5588517"/>
+            <a:off x="3205114" y="5596079"/>
             <a:ext cx="71597" cy="71597"/>
           </a:xfrm>
           <a:prstGeom prst="rect">
@@ -12321,7 +12190,7 @@
         </p:nvSpPr>
         <p:spPr>
           <a:xfrm>
-            <a:off x="2728606" y="3667518"/>
+            <a:off x="2728606" y="3711325"/>
             <a:ext cx="63629" cy="63629"/>
           </a:xfrm>
           <a:prstGeom prst="rect">
@@ -12364,7 +12233,7 @@
         </p:nvSpPr>
         <p:spPr>
           <a:xfrm>
-            <a:off x="4659015" y="4075209"/>
+            <a:off x="4659015" y="4111324"/>
             <a:ext cx="59418" cy="59418"/>
           </a:xfrm>
           <a:prstGeom prst="rect">
@@ -12407,7 +12276,7 @@
         </p:nvSpPr>
         <p:spPr>
           <a:xfrm>
-            <a:off x="2415436" y="4922847"/>
+            <a:off x="2415436" y="4942969"/>
             <a:ext cx="82285" cy="82285"/>
           </a:xfrm>
           <a:prstGeom prst="rect">
@@ -12450,7 +12319,7 @@
         </p:nvSpPr>
         <p:spPr>
           <a:xfrm>
-            <a:off x="4044070" y="5809433"/>
+            <a:off x="4044070" y="5812827"/>
             <a:ext cx="58950" cy="58950"/>
           </a:xfrm>
           <a:prstGeom prst="rect">
@@ -12493,7 +12362,7 @@
         </p:nvSpPr>
         <p:spPr>
           <a:xfrm>
-            <a:off x="4977012" y="5530789"/>
+            <a:off x="4977012" y="5539441"/>
             <a:ext cx="82530" cy="82530"/>
           </a:xfrm>
           <a:prstGeom prst="rect">
@@ -12536,7 +12405,7 @@
         </p:nvSpPr>
         <p:spPr>
           <a:xfrm>
-            <a:off x="1698153" y="5806340"/>
+            <a:off x="1698153" y="5809793"/>
             <a:ext cx="78908" cy="78908"/>
           </a:xfrm>
           <a:prstGeom prst="rect">
@@ -12579,7 +12448,7 @@
         </p:nvSpPr>
         <p:spPr>
           <a:xfrm>
-            <a:off x="4261157" y="5659925"/>
+            <a:off x="4261157" y="5666140"/>
             <a:ext cx="79945" cy="79945"/>
           </a:xfrm>
           <a:prstGeom prst="rect">
@@ -12622,7 +12491,7 @@
         </p:nvSpPr>
         <p:spPr>
           <a:xfrm>
-            <a:off x="1615187" y="5265469"/>
+            <a:off x="1615187" y="5279126"/>
             <a:ext cx="64283" cy="64283"/>
           </a:xfrm>
           <a:prstGeom prst="rect">
@@ -12665,7 +12534,7 @@
         </p:nvSpPr>
         <p:spPr>
           <a:xfrm>
-            <a:off x="4493059" y="4105152"/>
+            <a:off x="4493059" y="4140702"/>
             <a:ext cx="80159" cy="80159"/>
           </a:xfrm>
           <a:prstGeom prst="rect">
@@ -12708,7 +12577,7 @@
         </p:nvSpPr>
         <p:spPr>
           <a:xfrm>
-            <a:off x="2398894" y="5554450"/>
+            <a:off x="2398894" y="5562656"/>
             <a:ext cx="82161" cy="82161"/>
           </a:xfrm>
           <a:prstGeom prst="rect">
@@ -12751,7 +12620,7 @@
         </p:nvSpPr>
         <p:spPr>
           <a:xfrm>
-            <a:off x="1057494" y="4034144"/>
+            <a:off x="1057494" y="4071034"/>
             <a:ext cx="62298" cy="62298"/>
           </a:xfrm>
           <a:prstGeom prst="rect">
@@ -12794,7 +12663,7 @@
         </p:nvSpPr>
         <p:spPr>
           <a:xfrm>
-            <a:off x="4938675" y="4242524"/>
+            <a:off x="4938675" y="4275482"/>
             <a:ext cx="73754" cy="73754"/>
           </a:xfrm>
           <a:prstGeom prst="rect">
@@ -12837,7 +12706,7 @@
         </p:nvSpPr>
         <p:spPr>
           <a:xfrm>
-            <a:off x="3756201" y="5610485"/>
+            <a:off x="3756201" y="5617633"/>
             <a:ext cx="62404" cy="62404"/>
           </a:xfrm>
           <a:prstGeom prst="rect">
@@ -12880,7 +12749,7 @@
         </p:nvSpPr>
         <p:spPr>
           <a:xfrm>
-            <a:off x="1434728" y="5917595"/>
+            <a:off x="1434728" y="5918949"/>
             <a:ext cx="56823" cy="56823"/>
           </a:xfrm>
           <a:prstGeom prst="rect">
@@ -12923,7 +12792,7 @@
         </p:nvSpPr>
         <p:spPr>
           <a:xfrm>
-            <a:off x="1117540" y="5011747"/>
+            <a:off x="1117540" y="5030192"/>
             <a:ext cx="62935" cy="62935"/>
           </a:xfrm>
           <a:prstGeom prst="rect">
@@ -12966,7 +12835,7 @@
         </p:nvSpPr>
         <p:spPr>
           <a:xfrm>
-            <a:off x="2755793" y="5951120"/>
+            <a:off x="2755793" y="5951841"/>
             <a:ext cx="54521" cy="54521"/>
           </a:xfrm>
           <a:prstGeom prst="rect">
@@ -13009,7 +12878,7 @@
         </p:nvSpPr>
         <p:spPr>
           <a:xfrm>
-            <a:off x="1742256" y="3673715"/>
+            <a:off x="1742256" y="3717406"/>
             <a:ext cx="66241" cy="66241"/>
           </a:xfrm>
           <a:prstGeom prst="rect">
@@ -13052,7 +12921,7 @@
         </p:nvSpPr>
         <p:spPr>
           <a:xfrm>
-            <a:off x="4768676" y="4870915"/>
+            <a:off x="4768676" y="4892017"/>
             <a:ext cx="76605" cy="76605"/>
           </a:xfrm>
           <a:prstGeom prst="rect">
@@ -13095,7 +12964,7 @@
         </p:nvSpPr>
         <p:spPr>
           <a:xfrm>
-            <a:off x="3992882" y="4043607"/>
+            <a:off x="3992882" y="4080319"/>
             <a:ext cx="66067" cy="66067"/>
           </a:xfrm>
           <a:prstGeom prst="rect">
@@ -13138,7 +13007,7 @@
         </p:nvSpPr>
         <p:spPr>
           <a:xfrm>
-            <a:off x="4748907" y="5076165"/>
+            <a:off x="4748907" y="5093394"/>
             <a:ext cx="74556" cy="74556"/>
           </a:xfrm>
           <a:prstGeom prst="rect">
@@ -13181,7 +13050,7 @@
         </p:nvSpPr>
         <p:spPr>
           <a:xfrm>
-            <a:off x="3921764" y="4293888"/>
+            <a:off x="3921764" y="4325878"/>
             <a:ext cx="61604" cy="61604"/>
           </a:xfrm>
           <a:prstGeom prst="rect">
@@ -13224,7 +13093,7 @@
         </p:nvSpPr>
         <p:spPr>
           <a:xfrm>
-            <a:off x="2302297" y="5255607"/>
+            <a:off x="2302297" y="5269451"/>
             <a:ext cx="70570" cy="70570"/>
           </a:xfrm>
           <a:prstGeom prst="rect">
@@ -13267,7 +13136,7 @@
         </p:nvSpPr>
         <p:spPr>
           <a:xfrm>
-            <a:off x="2690172" y="5844811"/>
+            <a:off x="2690172" y="5847538"/>
             <a:ext cx="75065" cy="75065"/>
           </a:xfrm>
           <a:prstGeom prst="rect">
@@ -13310,7 +13179,7 @@
         </p:nvSpPr>
         <p:spPr>
           <a:xfrm>
-            <a:off x="3492840" y="4295409"/>
+            <a:off x="3492840" y="4327370"/>
             <a:ext cx="70333" cy="70333"/>
           </a:xfrm>
           <a:prstGeom prst="rect">
@@ -13353,7 +13222,7 @@
         </p:nvSpPr>
         <p:spPr>
           <a:xfrm>
-            <a:off x="2210504" y="4075466"/>
+            <a:off x="2210504" y="4111576"/>
             <a:ext cx="79031" cy="79031"/>
           </a:xfrm>
           <a:prstGeom prst="rect">
@@ -13396,7 +13265,7 @@
         </p:nvSpPr>
         <p:spPr>
           <a:xfrm>
-            <a:off x="3654102" y="4692900"/>
+            <a:off x="3654102" y="4717361"/>
             <a:ext cx="66464" cy="66464"/>
           </a:xfrm>
           <a:prstGeom prst="rect">
@@ -13439,7 +13308,7 @@
         </p:nvSpPr>
         <p:spPr>
           <a:xfrm>
-            <a:off x="3063498" y="5489507"/>
+            <a:off x="3063498" y="5498938"/>
             <a:ext cx="85398" cy="85398"/>
           </a:xfrm>
           <a:prstGeom prst="rect">
@@ -13482,7 +13351,7 @@
         </p:nvSpPr>
         <p:spPr>
           <a:xfrm>
-            <a:off x="1658366" y="3771633"/>
+            <a:off x="1658366" y="3813476"/>
             <a:ext cx="69145" cy="69145"/>
           </a:xfrm>
           <a:prstGeom prst="rect">
@@ -13525,7 +13394,7 @@
         </p:nvSpPr>
         <p:spPr>
           <a:xfrm>
-            <a:off x="3508254" y="3792452"/>
+            <a:off x="3508254" y="3833902"/>
             <a:ext cx="85112" cy="85112"/>
           </a:xfrm>
           <a:prstGeom prst="rect">
@@ -13568,7 +13437,7 @@
         </p:nvSpPr>
         <p:spPr>
           <a:xfrm>
-            <a:off x="3728539" y="4110500"/>
+            <a:off x="3728539" y="4145949"/>
             <a:ext cx="57575" cy="57575"/>
           </a:xfrm>
           <a:prstGeom prst="rect">
@@ -13611,7 +13480,7 @@
         </p:nvSpPr>
         <p:spPr>
           <a:xfrm>
-            <a:off x="1150280" y="5950394"/>
+            <a:off x="1150280" y="5951128"/>
             <a:ext cx="72649" cy="72649"/>
           </a:xfrm>
           <a:prstGeom prst="rect">
@@ -13654,7 +13523,7 @@
         </p:nvSpPr>
         <p:spPr>
           <a:xfrm>
-            <a:off x="2834066" y="5713411"/>
+            <a:off x="2834066" y="5718617"/>
             <a:ext cx="71347" cy="71347"/>
           </a:xfrm>
           <a:prstGeom prst="rect">
@@ -13697,7 +13566,7 @@
         </p:nvSpPr>
         <p:spPr>
           <a:xfrm>
-            <a:off x="3825478" y="4764114"/>
+            <a:off x="3825478" y="4787232"/>
             <a:ext cx="59215" cy="59215"/>
           </a:xfrm>
           <a:prstGeom prst="rect">
@@ -13740,7 +13609,7 @@
         </p:nvSpPr>
         <p:spPr>
           <a:xfrm>
-            <a:off x="3789548" y="5729217"/>
+            <a:off x="3789548" y="5734125"/>
             <a:ext cx="81763" cy="81763"/>
           </a:xfrm>
           <a:prstGeom prst="rect">
@@ -13783,7 +13652,7 @@
         </p:nvSpPr>
         <p:spPr>
           <a:xfrm>
-            <a:off x="4163164" y="4096447"/>
+            <a:off x="4163164" y="4132161"/>
             <a:ext cx="79703" cy="79703"/>
           </a:xfrm>
           <a:prstGeom prst="rect">
@@ -13826,7 +13695,7 @@
         </p:nvSpPr>
         <p:spPr>
           <a:xfrm>
-            <a:off x="3091412" y="3687847"/>
+            <a:off x="3091412" y="3731271"/>
             <a:ext cx="59406" cy="59406"/>
           </a:xfrm>
           <a:prstGeom prst="rect">
@@ -13869,7 +13738,7 @@
         </p:nvSpPr>
         <p:spPr>
           <a:xfrm>
-            <a:off x="2838369" y="5508120"/>
+            <a:off x="2838369" y="5517199"/>
             <a:ext cx="74709" cy="74709"/>
           </a:xfrm>
           <a:prstGeom prst="rect">
@@ -13912,7 +13781,7 @@
         </p:nvSpPr>
         <p:spPr>
           <a:xfrm>
-            <a:off x="3410287" y="5868257"/>
+            <a:off x="3410287" y="5870542"/>
             <a:ext cx="82896" cy="82896"/>
           </a:xfrm>
           <a:prstGeom prst="rect">
@@ -13955,7 +13824,7 @@
         </p:nvSpPr>
         <p:spPr>
           <a:xfrm>
-            <a:off x="4313708" y="5727667"/>
+            <a:off x="4313708" y="5732604"/>
             <a:ext cx="65900" cy="65900"/>
           </a:xfrm>
           <a:prstGeom prst="rect">
@@ -13998,7 +13867,7 @@
         </p:nvSpPr>
         <p:spPr>
           <a:xfrm>
-            <a:off x="2794965" y="3951825"/>
+            <a:off x="2794965" y="3990268"/>
             <a:ext cx="81802" cy="81802"/>
           </a:xfrm>
           <a:prstGeom prst="rect">
@@ -14041,7 +13910,7 @@
         </p:nvSpPr>
         <p:spPr>
           <a:xfrm>
-            <a:off x="2026641" y="4165261"/>
+            <a:off x="2026641" y="4199677"/>
             <a:ext cx="73615" cy="73615"/>
           </a:xfrm>
           <a:prstGeom prst="rect">
@@ -14084,7 +13953,7 @@
         </p:nvSpPr>
         <p:spPr>
           <a:xfrm>
-            <a:off x="2954139" y="4145891"/>
+            <a:off x="2954139" y="4180672"/>
             <a:ext cx="66380" cy="66380"/>
           </a:xfrm>
           <a:prstGeom prst="rect">
@@ -14127,7 +13996,7 @@
         </p:nvSpPr>
         <p:spPr>
           <a:xfrm>
-            <a:off x="2135834" y="4224569"/>
+            <a:off x="2135834" y="4257866"/>
             <a:ext cx="61985" cy="61985"/>
           </a:xfrm>
           <a:prstGeom prst="rect">
@@ -14170,7 +14039,7 @@
         </p:nvSpPr>
         <p:spPr>
           <a:xfrm>
-            <a:off x="1291680" y="3931646"/>
+            <a:off x="1291680" y="3970470"/>
             <a:ext cx="64301" cy="64301"/>
           </a:xfrm>
           <a:prstGeom prst="rect">
@@ -14213,7 +14082,7 @@
         </p:nvSpPr>
         <p:spPr>
           <a:xfrm>
-            <a:off x="3866893" y="3721796"/>
+            <a:off x="3866893" y="3764580"/>
             <a:ext cx="65200" cy="65200"/>
           </a:xfrm>
           <a:prstGeom prst="rect">
@@ -14256,7 +14125,7 @@
         </p:nvSpPr>
         <p:spPr>
           <a:xfrm>
-            <a:off x="2877305" y="3717039"/>
+            <a:off x="2877305" y="3759912"/>
             <a:ext cx="80755" cy="80755"/>
           </a:xfrm>
           <a:prstGeom prst="rect">
@@ -14299,7 +14168,7 @@
         </p:nvSpPr>
         <p:spPr>
           <a:xfrm>
-            <a:off x="4683349" y="4981477"/>
+            <a:off x="4683349" y="5000493"/>
             <a:ext cx="75731" cy="75731"/>
           </a:xfrm>
           <a:prstGeom prst="rect">
@@ -14342,7 +14211,7 @@
         </p:nvSpPr>
         <p:spPr>
           <a:xfrm>
-            <a:off x="2525311" y="3580447"/>
+            <a:off x="2525311" y="3625897"/>
             <a:ext cx="63157" cy="63157"/>
           </a:xfrm>
           <a:prstGeom prst="rect">
@@ -14385,7 +14254,7 @@
         </p:nvSpPr>
         <p:spPr>
           <a:xfrm>
-            <a:off x="4471887" y="5876474"/>
+            <a:off x="4471887" y="5878603"/>
             <a:ext cx="65618" cy="65618"/>
           </a:xfrm>
           <a:prstGeom prst="rect">
@@ -14428,7 +14297,7 @@
         </p:nvSpPr>
         <p:spPr>
           <a:xfrm>
-            <a:off x="3982992" y="5504368"/>
+            <a:off x="3982992" y="5513518"/>
             <a:ext cx="83130" cy="83130"/>
           </a:xfrm>
           <a:prstGeom prst="rect">
@@ -14471,7 +14340,7 @@
         </p:nvSpPr>
         <p:spPr>
           <a:xfrm>
-            <a:off x="1862996" y="4622260"/>
+            <a:off x="1862996" y="4648053"/>
             <a:ext cx="51353" cy="51353"/>
           </a:xfrm>
           <a:prstGeom prst="rect">
@@ -14514,7 +14383,7 @@
         </p:nvSpPr>
         <p:spPr>
           <a:xfrm>
-            <a:off x="3712401" y="5500186"/>
+            <a:off x="3712401" y="5509415"/>
             <a:ext cx="76779" cy="76779"/>
           </a:xfrm>
           <a:prstGeom prst="rect">
@@ -14557,7 +14426,7 @@
         </p:nvSpPr>
         <p:spPr>
           <a:xfrm>
-            <a:off x="4743849" y="5942606"/>
+            <a:off x="4743849" y="5943487"/>
             <a:ext cx="69828" cy="69828"/>
           </a:xfrm>
           <a:prstGeom prst="rect">
@@ -14600,7 +14469,7 @@
         </p:nvSpPr>
         <p:spPr>
           <a:xfrm>
-            <a:off x="3395640" y="5172714"/>
+            <a:off x="3395640" y="5188122"/>
             <a:ext cx="53362" cy="53362"/>
           </a:xfrm>
           <a:prstGeom prst="rect">
@@ -14643,7 +14512,7 @@
         </p:nvSpPr>
         <p:spPr>
           <a:xfrm>
-            <a:off x="1518496" y="4684929"/>
+            <a:off x="1518496" y="4709540"/>
             <a:ext cx="52131" cy="52131"/>
           </a:xfrm>
           <a:prstGeom prst="rect">
@@ -14686,7 +14555,7 @@
         </p:nvSpPr>
         <p:spPr>
           <a:xfrm>
-            <a:off x="2307110" y="4667969"/>
+            <a:off x="2307110" y="4692900"/>
             <a:ext cx="62636" cy="62636"/>
           </a:xfrm>
           <a:prstGeom prst="rect">
@@ -14729,7 +14598,7 @@
         </p:nvSpPr>
         <p:spPr>
           <a:xfrm>
-            <a:off x="2105090" y="5871079"/>
+            <a:off x="2105090" y="5873310"/>
             <a:ext cx="65711" cy="65711"/>
           </a:xfrm>
           <a:prstGeom prst="rect">
@@ -14772,8 +14641,8 @@
         </p:nvSpPr>
         <p:spPr>
           <a:xfrm>
-            <a:off x="914400" y="6172200"/>
-            <a:ext cx="4389120" cy="292608"/>
+            <a:off x="914400" y="6217920"/>
+            <a:ext cx="4389120" cy="274320"/>
           </a:xfrm>
           <a:prstGeom prst="rect">
             <a:avLst/>
@@ -14786,14 +14655,14 @@
           </a:bodyPr>
           <a:lstStyle/>
           <a:p>
-            <a:pPr algn="l"/>
+            <a:pPr algn="r"/>
             <a:r>
               <a:rPr sz="1000" b="0" i="1">
                 <a:solidFill>
                   <a:srgbClr val="E63A46"/>
                 </a:solidFill>
               </a:rPr>
-              <a:t>Trend line: nearly flat (r = −0.06)</a:t>
+              <a:t>קו מגמה: כמעט שטוח (r = −0.06)</a:t>
             </a:r>
           </a:p>
         </p:txBody>
@@ -14852,7 +14721,7 @@
         <p:spPr>
           <a:xfrm>
             <a:off x="5806440" y="3200400"/>
-            <a:ext cx="1828800" cy="347472"/>
+            <a:ext cx="5897880" cy="365760"/>
           </a:xfrm>
           <a:prstGeom prst="rect">
             <a:avLst/>
@@ -14865,14 +14734,14 @@
           </a:bodyPr>
           <a:lstStyle/>
           <a:p>
-            <a:pPr algn="l"/>
-            <a:r>
-              <a:rPr sz="1100" b="1" i="0">
+            <a:pPr algn="r"/>
+            <a:r>
+              <a:rPr sz="1400" b="1" i="0">
                 <a:solidFill>
                   <a:srgbClr val="E63A46"/>
                 </a:solidFill>
               </a:rPr>
-              <a:t>💡 Insight 1</a:t>
+              <a:t>💡 תובנה 1 — אין קשר מחיר–איכות</a:t>
             </a:r>
           </a:p>
         </p:txBody>
@@ -14885,8 +14754,8 @@
         </p:nvSpPr>
         <p:spPr>
           <a:xfrm>
-            <a:off x="5806440" y="3200400"/>
-            <a:ext cx="5852160" cy="347472"/>
+            <a:off x="5806440" y="3593592"/>
+            <a:ext cx="5897880" cy="566928"/>
           </a:xfrm>
           <a:prstGeom prst="rect">
             <a:avLst/>
@@ -14899,57 +14768,23 @@
           </a:bodyPr>
           <a:lstStyle/>
           <a:p>
-            <a:pPr algn="l"/>
-            <a:r>
-              <a:rPr sz="1400" b="1" i="0">
+            <a:pPr algn="r"/>
+            <a:r>
+              <a:rPr sz="1200" b="0" i="0">
                 <a:solidFill>
                   <a:srgbClr val="FFFFFF"/>
                 </a:solidFill>
               </a:rPr>
-              <a:t>No Price–Quality Link</a:t>
-            </a:r>
-          </a:p>
-        </p:txBody>
-      </p:sp>
-      <p:sp>
-        <p:nvSpPr>
-          <p:cNvPr id="176" name="TextBox 175"/>
-          <p:cNvSpPr txBox="1"/>
-          <p:nvPr/>
-        </p:nvSpPr>
-        <p:spPr>
-          <a:xfrm>
-            <a:off x="5806440" y="3566160"/>
-            <a:ext cx="5852160" cy="594360"/>
-          </a:xfrm>
-          <a:prstGeom prst="rect">
-            <a:avLst/>
-          </a:prstGeom>
-          <a:noFill/>
-        </p:spPr>
-        <p:txBody>
-          <a:bodyPr wrap="square">
-            <a:spAutoFit/>
-          </a:bodyPr>
-          <a:lstStyle/>
-          <a:p>
-            <a:pPr algn="l"/>
-            <a:r>
-              <a:rPr sz="1200" b="0" i="0">
-                <a:solidFill>
-                  <a:srgbClr val="8B8B8B"/>
-                </a:solidFill>
-              </a:rPr>
-              <a:t>r = −0.06. A ₪58 shawarma is
-statistically no better than ₪44.
-Price alone is a useless filter.</a:t>
-            </a:r>
-          </a:p>
-        </p:txBody>
-      </p:sp>
-      <p:sp>
-        <p:nvSpPr>
-          <p:cNvPr id="177" name="Rectangle 176"/>
+              <a:t>r = −0.06. שווארמה ב-₪58 אינה
+טובה מ-₪44 מבחינה סטטיסטית.
+מחיר לבדו — פילטר חסר ערך.</a:t>
+            </a:r>
+          </a:p>
+        </p:txBody>
+      </p:sp>
+      <p:sp>
+        <p:nvSpPr>
+          <p:cNvPr id="176" name="Rectangle 175"/>
           <p:cNvSpPr/>
           <p:nvPr/>
         </p:nvSpPr>
@@ -14994,14 +14829,14 @@
       </p:sp>
       <p:sp>
         <p:nvSpPr>
-          <p:cNvPr id="178" name="TextBox 177"/>
+          <p:cNvPr id="177" name="TextBox 176"/>
           <p:cNvSpPr txBox="1"/>
           <p:nvPr/>
         </p:nvSpPr>
         <p:spPr>
           <a:xfrm>
             <a:off x="5806440" y="4343400"/>
-            <a:ext cx="1828800" cy="347472"/>
+            <a:ext cx="5897880" cy="365760"/>
           </a:xfrm>
           <a:prstGeom prst="rect">
             <a:avLst/>
@@ -15014,28 +14849,28 @@
           </a:bodyPr>
           <a:lstStyle/>
           <a:p>
-            <a:pPr algn="l"/>
-            <a:r>
-              <a:rPr sz="1100" b="1" i="0">
+            <a:pPr algn="r"/>
+            <a:r>
+              <a:rPr sz="1400" b="1" i="0">
                 <a:solidFill>
                   <a:srgbClr val="C9A84C"/>
                 </a:solidFill>
               </a:rPr>
-              <a:t>💡 Insight 2</a:t>
-            </a:r>
-          </a:p>
-        </p:txBody>
-      </p:sp>
-      <p:sp>
-        <p:nvSpPr>
-          <p:cNvPr id="179" name="TextBox 178"/>
+              <a:t>💡 תובנה 2 — מחירים בטווח צר בלבד</a:t>
+            </a:r>
+          </a:p>
+        </p:txBody>
+      </p:sp>
+      <p:sp>
+        <p:nvSpPr>
+          <p:cNvPr id="178" name="TextBox 177"/>
           <p:cNvSpPr txBox="1"/>
           <p:nvPr/>
         </p:nvSpPr>
         <p:spPr>
           <a:xfrm>
-            <a:off x="5806440" y="4343400"/>
-            <a:ext cx="5852160" cy="347472"/>
+            <a:off x="5806440" y="4736592"/>
+            <a:ext cx="5897880" cy="566928"/>
           </a:xfrm>
           <a:prstGeom prst="rect">
             <a:avLst/>
@@ -15048,57 +14883,23 @@
           </a:bodyPr>
           <a:lstStyle/>
           <a:p>
-            <a:pPr algn="l"/>
-            <a:r>
-              <a:rPr sz="1400" b="1" i="0">
+            <a:pPr algn="r"/>
+            <a:r>
+              <a:rPr sz="1200" b="0" i="0">
                 <a:solidFill>
                   <a:srgbClr val="FFFFFF"/>
                 </a:solidFill>
               </a:rPr>
-              <a:t>Prices Cluster Narrowly</a:t>
-            </a:r>
-          </a:p>
-        </p:txBody>
-      </p:sp>
-      <p:sp>
-        <p:nvSpPr>
-          <p:cNvPr id="180" name="TextBox 179"/>
-          <p:cNvSpPr txBox="1"/>
-          <p:nvPr/>
-        </p:nvSpPr>
-        <p:spPr>
-          <a:xfrm>
-            <a:off x="5806440" y="4709160"/>
-            <a:ext cx="5852160" cy="594360"/>
-          </a:xfrm>
-          <a:prstGeom prst="rect">
-            <a:avLst/>
-          </a:prstGeom>
-          <a:noFill/>
-        </p:spPr>
-        <p:txBody>
-          <a:bodyPr wrap="square">
-            <a:spAutoFit/>
-          </a:bodyPr>
-          <a:lstStyle/>
-          <a:p>
-            <a:pPr algn="l"/>
-            <a:r>
-              <a:rPr sz="1200" b="0" i="0">
-                <a:solidFill>
-                  <a:srgbClr val="8B8B8B"/>
-                </a:solidFill>
-              </a:rPr>
-              <a:t>IQR = only ₪5 (₪43–₪48).
-50% of venues within 5 NIS.
-Rating + distance must be added.</a:t>
-            </a:r>
-          </a:p>
-        </p:txBody>
-      </p:sp>
-      <p:sp>
-        <p:nvSpPr>
-          <p:cNvPr id="181" name="Rectangle 180"/>
+              <a:t>IQR = ₪5 בלבד (₪43–₪48).
+50% מהמסעדות בתוך 5 שקלים.
+דירוג + מרחק חייבים להיכנס.</a:t>
+            </a:r>
+          </a:p>
+        </p:txBody>
+      </p:sp>
+      <p:sp>
+        <p:nvSpPr>
+          <p:cNvPr id="179" name="Rectangle 178"/>
           <p:cNvSpPr/>
           <p:nvPr/>
         </p:nvSpPr>
@@ -15143,14 +14944,14 @@
       </p:sp>
       <p:sp>
         <p:nvSpPr>
-          <p:cNvPr id="182" name="TextBox 181"/>
+          <p:cNvPr id="180" name="TextBox 179"/>
           <p:cNvSpPr txBox="1"/>
           <p:nvPr/>
         </p:nvSpPr>
         <p:spPr>
           <a:xfrm>
             <a:off x="5806440" y="5486400"/>
-            <a:ext cx="1828800" cy="347472"/>
+            <a:ext cx="5897880" cy="365760"/>
           </a:xfrm>
           <a:prstGeom prst="rect">
             <a:avLst/>
@@ -15163,28 +14964,28 @@
           </a:bodyPr>
           <a:lstStyle/>
           <a:p>
-            <a:pPr algn="l"/>
-            <a:r>
-              <a:rPr sz="1100" b="1" i="0">
+            <a:pPr algn="r"/>
+            <a:r>
+              <a:rPr sz="1400" b="1" i="0">
                 <a:solidFill>
                   <a:srgbClr val="2A9D8F"/>
                 </a:solidFill>
               </a:rPr>
-              <a:t>💡 Insight 3</a:t>
-            </a:r>
-          </a:p>
-        </p:txBody>
-      </p:sp>
-      <p:sp>
-        <p:nvSpPr>
-          <p:cNvPr id="183" name="TextBox 182"/>
+              <a:t>💡 תובנה 3 — ארביטראז׳ גיאוגרפי: ₪13.6</a:t>
+            </a:r>
+          </a:p>
+        </p:txBody>
+      </p:sp>
+      <p:sp>
+        <p:nvSpPr>
+          <p:cNvPr id="181" name="TextBox 180"/>
           <p:cNvSpPr txBox="1"/>
           <p:nvPr/>
         </p:nvSpPr>
         <p:spPr>
           <a:xfrm>
-            <a:off x="5806440" y="5486400"/>
-            <a:ext cx="5852160" cy="347472"/>
+            <a:off x="5806440" y="5879592"/>
+            <a:ext cx="5897880" cy="566928"/>
           </a:xfrm>
           <a:prstGeom prst="rect">
             <a:avLst/>
@@ -15197,50 +14998,16 @@
           </a:bodyPr>
           <a:lstStyle/>
           <a:p>
-            <a:pPr algn="l"/>
-            <a:r>
-              <a:rPr sz="1400" b="1" i="0">
+            <a:pPr algn="r"/>
+            <a:r>
+              <a:rPr sz="1200" b="0" i="0">
                 <a:solidFill>
                   <a:srgbClr val="FFFFFF"/>
                 </a:solidFill>
               </a:rPr>
-              <a:t>Geographic Arbitrage: ₪13.6</a:t>
-            </a:r>
-          </a:p>
-        </p:txBody>
-      </p:sp>
-      <p:sp>
-        <p:nvSpPr>
-          <p:cNvPr id="184" name="TextBox 183"/>
-          <p:cNvSpPr txBox="1"/>
-          <p:nvPr/>
-        </p:nvSpPr>
-        <p:spPr>
-          <a:xfrm>
-            <a:off x="5806440" y="5852160"/>
-            <a:ext cx="5852160" cy="594360"/>
-          </a:xfrm>
-          <a:prstGeom prst="rect">
-            <a:avLst/>
-          </a:prstGeom>
-          <a:noFill/>
-        </p:spPr>
-        <p:txBody>
-          <a:bodyPr wrap="square">
-            <a:spAutoFit/>
-          </a:bodyPr>
-          <a:lstStyle/>
-          <a:p>
-            <a:pPr algn="l"/>
-            <a:r>
-              <a:rPr sz="1200" b="0" i="0">
-                <a:solidFill>
-                  <a:srgbClr val="8B8B8B"/>
-                </a:solidFill>
-              </a:rPr>
-              <a:t>City-level avg price varies ₪13.6.
-Location is a meaningful signal.
-Coordinates are essential.</a:t>
+              <a:t>ממוצע מחיר עירוני נע ב-₪13.6.
+מיקום הוא אות משמעותי.
+קואורדינטות הכרחיות למודל.</a:t>
             </a:r>
           </a:p>
         </p:txBody>
@@ -15314,7 +15081,7 @@
         </p:nvSpPr>
         <p:spPr>
           <a:xfrm>
-            <a:off x="365760" y="182880"/>
+            <a:off x="9509760" y="182880"/>
             <a:ext cx="2286000" cy="502920"/>
           </a:xfrm>
           <a:prstGeom prst="rect">
@@ -15359,7 +15126,7 @@
         </p:nvSpPr>
         <p:spPr>
           <a:xfrm>
-            <a:off x="365760" y="182880"/>
+            <a:off x="9509760" y="182880"/>
             <a:ext cx="2286000" cy="502920"/>
           </a:xfrm>
           <a:prstGeom prst="rect">
@@ -15393,7 +15160,7 @@
         </p:nvSpPr>
         <p:spPr>
           <a:xfrm>
-            <a:off x="2834640" y="228600"/>
+            <a:off x="365760" y="228600"/>
             <a:ext cx="8961120" cy="411480"/>
           </a:xfrm>
           <a:prstGeom prst="rect">
@@ -15407,14 +15174,14 @@
           </a:bodyPr>
           <a:lstStyle/>
           <a:p>
-            <a:pPr algn="l"/>
+            <a:pPr algn="r"/>
             <a:r>
               <a:rPr sz="1200" b="0" i="0">
                 <a:solidFill>
                   <a:srgbClr val="8B8B8B"/>
                 </a:solidFill>
               </a:rPr>
-              <a:t>Section 4 / 4</a:t>
+              <a:t>חלק 4 מתוך 4</a:t>
             </a:r>
           </a:p>
         </p:txBody>
@@ -15441,14 +15208,14 @@
           </a:bodyPr>
           <a:lstStyle/>
           <a:p>
-            <a:pPr algn="l"/>
+            <a:pPr algn="r"/>
             <a:r>
               <a:rPr sz="3000" b="1" i="0">
                 <a:solidFill>
                   <a:srgbClr val="F0D080"/>
                 </a:solidFill>
               </a:rPr>
-              <a:t>KPI &amp; Next Steps — What We Are Building in M3</a:t>
+              <a:t>KPI + הצעד הבא — מה אנחנו בונים ב-M3</a:t>
             </a:r>
           </a:p>
         </p:txBody>
@@ -15584,7 +15351,7 @@
         <p:spPr>
           <a:xfrm>
             <a:off x="365760" y="2651760"/>
-            <a:ext cx="3749039" cy="502920"/>
+            <a:ext cx="3749039" cy="457200"/>
           </a:xfrm>
           <a:prstGeom prst="rect">
             <a:avLst/>
@@ -15617,8 +15384,8 @@
         </p:nvSpPr>
         <p:spPr>
           <a:xfrm>
-            <a:off x="365760" y="3127248"/>
-            <a:ext cx="3749039" cy="411480"/>
+            <a:off x="365760" y="3090672"/>
+            <a:ext cx="3749039" cy="457200"/>
           </a:xfrm>
           <a:prstGeom prst="rect">
             <a:avLst/>
@@ -15638,8 +15405,8 @@
                   <a:srgbClr val="8B8B8B"/>
                 </a:solidFill>
               </a:rPr>
-              <a:t>Cluster quality target
-vs. random ≈ 0.10</a:t>
+              <a:t>יעד איכות האשכולות
+מול ממוצע רנדומלי ≈ 0.10</a:t>
             </a:r>
           </a:p>
         </p:txBody>
@@ -15732,7 +15499,7 @@
         <p:spPr>
           <a:xfrm>
             <a:off x="4306823" y="2651760"/>
-            <a:ext cx="3749039" cy="502920"/>
+            <a:ext cx="3749039" cy="457200"/>
           </a:xfrm>
           <a:prstGeom prst="rect">
             <a:avLst/>
@@ -15752,8 +15519,7 @@
                   <a:srgbClr val="FFFFFF"/>
                 </a:solidFill>
               </a:rPr>
-              <a:t>Recommendation
-Accuracy</a:t>
+              <a:t>דיוק ההמלצה</a:t>
             </a:r>
           </a:p>
         </p:txBody>
@@ -15766,8 +15532,8 @@
         </p:nvSpPr>
         <p:spPr>
           <a:xfrm>
-            <a:off x="4306823" y="3127248"/>
-            <a:ext cx="3749039" cy="411480"/>
+            <a:off x="4306823" y="3090672"/>
+            <a:ext cx="3749039" cy="457200"/>
           </a:xfrm>
           <a:prstGeom prst="rect">
             <a:avLst/>
@@ -15787,8 +15553,8 @@
                   <a:srgbClr val="8B8B8B"/>
                 </a:solidFill>
               </a:rPr>
-              <a:t>Manual eval on
-50 test cases</a:t>
+              <a:t>הערכה ידנית
+על 50 מקרי בדיקה</a:t>
             </a:r>
           </a:p>
         </p:txBody>
@@ -15867,7 +15633,7 @@
                   <a:srgbClr val="C9A84C"/>
                 </a:solidFill>
               </a:rPr>
-              <a:t>&lt; 3 sec</a:t>
+              <a:t>&lt; 3 שנ׳</a:t>
             </a:r>
           </a:p>
         </p:txBody>
@@ -15881,7 +15647,7 @@
         <p:spPr>
           <a:xfrm>
             <a:off x="8247886" y="2651760"/>
-            <a:ext cx="3749039" cy="502920"/>
+            <a:ext cx="3749039" cy="457200"/>
           </a:xfrm>
           <a:prstGeom prst="rect">
             <a:avLst/>
@@ -15901,7 +15667,7 @@
                   <a:srgbClr val="FFFFFF"/>
                 </a:solidFill>
               </a:rPr>
-              <a:t>Response Time</a:t>
+              <a:t>זמן תגובה</a:t>
             </a:r>
           </a:p>
         </p:txBody>
@@ -15914,8 +15680,8 @@
         </p:nvSpPr>
         <p:spPr>
           <a:xfrm>
-            <a:off x="8247886" y="3127248"/>
-            <a:ext cx="3749039" cy="411480"/>
+            <a:off x="8247886" y="3090672"/>
+            <a:ext cx="3749039" cy="457200"/>
           </a:xfrm>
           <a:prstGeom prst="rect">
             <a:avLst/>
@@ -15935,8 +15701,7 @@
                   <a:srgbClr val="8B8B8B"/>
                 </a:solidFill>
               </a:rPr>
-              <a:t>GPS lock →
-ranked venue list</a:t>
+              <a:t>GPS → רשימה ממוינת</a:t>
             </a:r>
           </a:p>
         </p:txBody>
@@ -16051,14 +15816,14 @@
           </a:bodyPr>
           <a:lstStyle/>
           <a:p>
-            <a:pPr algn="l"/>
+            <a:pPr algn="r"/>
             <a:r>
               <a:rPr sz="1500" b="1" i="0">
                 <a:solidFill>
                   <a:srgbClr val="C9A84C"/>
                 </a:solidFill>
               </a:rPr>
-              <a:t>Baseline We Must Beat</a:t>
+              <a:t>ה-Baseline שעלינו לנצח</a:t>
             </a:r>
           </a:p>
         </p:txBody>
@@ -16072,7 +15837,7 @@
         <p:spPr>
           <a:xfrm>
             <a:off x="502920" y="4526280"/>
-            <a:ext cx="1828800" cy="411480"/>
+            <a:ext cx="2011680" cy="411480"/>
           </a:xfrm>
           <a:prstGeom prst="rect">
             <a:avLst/>
@@ -16085,14 +15850,14 @@
           </a:bodyPr>
           <a:lstStyle/>
           <a:p>
-            <a:pPr algn="l"/>
+            <a:pPr algn="r"/>
             <a:r>
               <a:rPr sz="1200" b="1" i="0">
                 <a:solidFill>
                   <a:srgbClr val="C9A84C"/>
                 </a:solidFill>
               </a:rPr>
-              <a:t>Current baseline:</a:t>
+              <a:t>:ה-Baseline הנוכחי:</a:t>
             </a:r>
           </a:p>
         </p:txBody>
@@ -16105,8 +15870,8 @@
         </p:nvSpPr>
         <p:spPr>
           <a:xfrm>
-            <a:off x="2377440" y="4526280"/>
-            <a:ext cx="3291840" cy="411480"/>
+            <a:off x="2560320" y="4526280"/>
+            <a:ext cx="3108960" cy="411480"/>
           </a:xfrm>
           <a:prstGeom prst="rect">
             <a:avLst/>
@@ -16119,14 +15884,14 @@
           </a:bodyPr>
           <a:lstStyle/>
           <a:p>
-            <a:pPr algn="l"/>
+            <a:pPr algn="r"/>
             <a:r>
               <a:rPr sz="1200" b="0" i="0">
                 <a:solidFill>
                   <a:srgbClr val="FFFFFF"/>
                 </a:solidFill>
               </a:rPr>
-              <a:t>Sort by distance only — Google Maps default</a:t>
+              <a:t>מיון לפי מרחק בלבד — ברירת המחדל של גוגל מפות</a:t>
             </a:r>
           </a:p>
         </p:txBody>
@@ -16140,7 +15905,7 @@
         <p:spPr>
           <a:xfrm>
             <a:off x="502920" y="4983480"/>
-            <a:ext cx="1828800" cy="411480"/>
+            <a:ext cx="2011680" cy="411480"/>
           </a:xfrm>
           <a:prstGeom prst="rect">
             <a:avLst/>
@@ -16153,14 +15918,14 @@
           </a:bodyPr>
           <a:lstStyle/>
           <a:p>
-            <a:pPr algn="l"/>
+            <a:pPr algn="r"/>
             <a:r>
               <a:rPr sz="1200" b="1" i="0">
                 <a:solidFill>
                   <a:srgbClr val="C9A84C"/>
                 </a:solidFill>
               </a:rPr>
-              <a:t>Its flaw:</a:t>
+              <a:t>:הכשל שלו:</a:t>
             </a:r>
           </a:p>
         </p:txBody>
@@ -16173,8 +15938,8 @@
         </p:nvSpPr>
         <p:spPr>
           <a:xfrm>
-            <a:off x="2377440" y="4983480"/>
-            <a:ext cx="3291840" cy="411480"/>
+            <a:off x="2560320" y="4983480"/>
+            <a:ext cx="3108960" cy="411480"/>
           </a:xfrm>
           <a:prstGeom prst="rect">
             <a:avLst/>
@@ -16187,14 +15952,14 @@
           </a:bodyPr>
           <a:lstStyle/>
           <a:p>
-            <a:pPr algn="l"/>
+            <a:pPr algn="r"/>
             <a:r>
               <a:rPr sz="1200" b="0" i="0">
                 <a:solidFill>
                   <a:srgbClr val="FFFFFF"/>
                 </a:solidFill>
               </a:rPr>
-              <a:t>Ignores price &amp; rating entirely</a:t>
+              <a:t>מתעלם לחלוטין ממחיר ודירוג</a:t>
             </a:r>
           </a:p>
         </p:txBody>
@@ -16208,7 +15973,7 @@
         <p:spPr>
           <a:xfrm>
             <a:off x="502920" y="5440680"/>
-            <a:ext cx="1828800" cy="411480"/>
+            <a:ext cx="2011680" cy="411480"/>
           </a:xfrm>
           <a:prstGeom prst="rect">
             <a:avLst/>
@@ -16221,14 +15986,14 @@
           </a:bodyPr>
           <a:lstStyle/>
           <a:p>
-            <a:pPr algn="l"/>
+            <a:pPr algn="r"/>
             <a:r>
               <a:rPr sz="1200" b="1" i="0">
                 <a:solidFill>
                   <a:srgbClr val="C9A84C"/>
                 </a:solidFill>
               </a:rPr>
-              <a:t>Our advantage:</a:t>
+              <a:t>:היתרון שלנו:</a:t>
             </a:r>
           </a:p>
         </p:txBody>
@@ -16241,8 +16006,8 @@
         </p:nvSpPr>
         <p:spPr>
           <a:xfrm>
-            <a:off x="2377440" y="5440680"/>
-            <a:ext cx="3291840" cy="411480"/>
+            <a:off x="2560320" y="5440680"/>
+            <a:ext cx="3108960" cy="411480"/>
           </a:xfrm>
           <a:prstGeom prst="rect">
             <a:avLst/>
@@ -16255,14 +16020,14 @@
           </a:bodyPr>
           <a:lstStyle/>
           <a:p>
-            <a:pPr algn="l"/>
+            <a:pPr algn="r"/>
             <a:r>
               <a:rPr sz="1200" b="0" i="0">
                 <a:solidFill>
                   <a:srgbClr val="FFFFFF"/>
                 </a:solidFill>
               </a:rPr>
-              <a:t>K-Means fuses [price, rating, distance_km] into one score</a:t>
+              <a:t>K-Means משלב [מחיר, דירוג, distance_km] לציון אחד</a:t>
             </a:r>
           </a:p>
         </p:txBody>
@@ -16276,7 +16041,7 @@
         <p:spPr>
           <a:xfrm>
             <a:off x="502920" y="5897880"/>
-            <a:ext cx="1828800" cy="411480"/>
+            <a:ext cx="2011680" cy="411480"/>
           </a:xfrm>
           <a:prstGeom prst="rect">
             <a:avLst/>
@@ -16289,14 +16054,14 @@
           </a:bodyPr>
           <a:lstStyle/>
           <a:p>
-            <a:pPr algn="l"/>
+            <a:pPr algn="r"/>
             <a:r>
               <a:rPr sz="1200" b="1" i="0">
                 <a:solidFill>
                   <a:srgbClr val="C9A84C"/>
                 </a:solidFill>
               </a:rPr>
-              <a:t>Success condition:</a:t>
+              <a:t>:תנאי הצלחה:</a:t>
             </a:r>
           </a:p>
         </p:txBody>
@@ -16309,8 +16074,8 @@
         </p:nvSpPr>
         <p:spPr>
           <a:xfrm>
-            <a:off x="2377440" y="5897880"/>
-            <a:ext cx="3291840" cy="411480"/>
+            <a:off x="2560320" y="5897880"/>
+            <a:ext cx="3108960" cy="411480"/>
           </a:xfrm>
           <a:prstGeom prst="rect">
             <a:avLst/>
@@ -16323,14 +16088,14 @@
           </a:bodyPr>
           <a:lstStyle/>
           <a:p>
-            <a:pPr algn="l"/>
+            <a:pPr algn="r"/>
             <a:r>
               <a:rPr sz="1200" b="0" i="0">
                 <a:solidFill>
                   <a:srgbClr val="FFFFFF"/>
                 </a:solidFill>
               </a:rPr>
-              <a:t>Silhouette ≥ 0.45 on held-out 15% test split</a:t>
+              <a:t>Silhouette ≥ 0.45 על 15% test split</a:t>
             </a:r>
           </a:p>
         </p:txBody>
@@ -16402,14 +16167,14 @@
           </a:bodyPr>
           <a:lstStyle/>
           <a:p>
-            <a:pPr algn="l"/>
+            <a:pPr algn="r"/>
             <a:r>
               <a:rPr sz="1500" b="1" i="0">
                 <a:solidFill>
                   <a:srgbClr val="C9A84C"/>
                 </a:solidFill>
               </a:rPr>
-              <a:t>🚀  M3 — What We Build Next</a:t>
+              <a:t>🚀  תוכנית M3 — מה אנחנו בונים</a:t>
             </a:r>
           </a:p>
         </p:txBody>
@@ -16436,14 +16201,14 @@
           </a:bodyPr>
           <a:lstStyle/>
           <a:p>
-            <a:pPr algn="l"/>
+            <a:pPr algn="r"/>
             <a:r>
               <a:rPr sz="1200" b="0" i="0">
                 <a:solidFill>
                   <a:srgbClr val="FFFFFF"/>
                 </a:solidFill>
               </a:rPr>
-              <a:t>  1.  Normalize [price, rating, distance_km] with StandardScaler</a:t>
+              <a:t>.1  נרמול פיצ׳רים עם StandardScaler</a:t>
             </a:r>
           </a:p>
         </p:txBody>
@@ -16470,14 +16235,14 @@
           </a:bodyPr>
           <a:lstStyle/>
           <a:p>
-            <a:pPr algn="l"/>
+            <a:pPr algn="r"/>
             <a:r>
               <a:rPr sz="1200" b="0" i="0">
                 <a:solidFill>
                   <a:srgbClr val="FFFFFF"/>
                 </a:solidFill>
               </a:rPr>
-              <a:t>  2.  Train K-Means: sweep k ∈ {3…8} via Elbow + Silhouette</a:t>
+              <a:t>.2  אימון K-Means: סריקת k ∈ {3...8} (Elbow + Silhouette)</a:t>
             </a:r>
           </a:p>
         </p:txBody>
@@ -16504,14 +16269,14 @@
           </a:bodyPr>
           <a:lstStyle/>
           <a:p>
-            <a:pPr algn="l"/>
+            <a:pPr algn="r"/>
             <a:r>
               <a:rPr sz="1200" b="0" i="0">
                 <a:solidFill>
                   <a:srgbClr val="FFFFFF"/>
                 </a:solidFill>
               </a:rPr>
-              <a:t>  3.  Evaluate on 15% test split — target Silhouette ≥ 0.45</a:t>
+              <a:t>.3  הערכה על 15% test split — יעד: Silhouette ≥ 0.45</a:t>
             </a:r>
           </a:p>
         </p:txBody>
@@ -16538,14 +16303,14 @@
           </a:bodyPr>
           <a:lstStyle/>
           <a:p>
-            <a:pPr algn="l"/>
+            <a:pPr algn="r"/>
             <a:r>
               <a:rPr sz="1200" b="0" i="0">
                 <a:solidFill>
                   <a:srgbClr val="FFFFFF"/>
                 </a:solidFill>
               </a:rPr>
-              <a:t>  4.  Build scoring function: rank = f(cluster, price, rating, distance)</a:t>
+              <a:t>.4  פונקציית ניקוד: rank = f(cluster, price, rating, distance)</a:t>
             </a:r>
           </a:p>
         </p:txBody>
@@ -16572,14 +16337,14 @@
           </a:bodyPr>
           <a:lstStyle/>
           <a:p>
-            <a:pPr algn="l"/>
+            <a:pPr algn="r"/>
             <a:r>
               <a:rPr sz="1200" b="0" i="0">
                 <a:solidFill>
                   <a:srgbClr val="FFFFFF"/>
                 </a:solidFill>
               </a:rPr>
-              <a:t>  5.  Add Recommend tab in Streamlit: GPS → ranked list in &lt; 3 sec</a:t>
+              <a:t>.5  לשונית ״המלץ עלי״ — GPS → רשימה ממוינת &lt; 3 שנ׳</a:t>
             </a:r>
           </a:p>
         </p:txBody>

</xml_diff>